<commit_message>
Idea deck: remove the template footer band, keep a plain page number
Co-Authored-By: Claude Opus 5 <noreply@anthropic.com>
</commit_message>
<xml_diff>
--- a/docs/FireOrbit_SIH26162_ThermalSentinel.pptx
+++ b/docs/FireOrbit_SIH26162_ThermalSentinel.pptx
@@ -232,7 +232,7 @@
           </c:val>
           <c:extLst>
             <c:ext xmlns:c16="http://schemas.microsoft.com/office/drawing/2014/chart" uri="{C3380CC4-5D6E-409C-BE32-E72D297353CC}">
-              <c16:uniqueId val="{00000000-827D-4B7E-B426-29CD8692772C}"/>
+              <c16:uniqueId val="{00000000-2848-4F59-92BE-3417BEC30136}"/>
             </c:ext>
           </c:extLst>
         </c:ser>
@@ -337,7 +337,7 @@
           </c:val>
           <c:extLst>
             <c:ext xmlns:c16="http://schemas.microsoft.com/office/drawing/2014/chart" uri="{C3380CC4-5D6E-409C-BE32-E72D297353CC}">
-              <c16:uniqueId val="{00000001-827D-4B7E-B426-29CD8692772C}"/>
+              <c16:uniqueId val="{00000001-2848-4F59-92BE-3417BEC30136}"/>
             </c:ext>
           </c:extLst>
         </c:ser>
@@ -511,7 +511,7 @@
     </p:spTree>
     <p:extLst>
       <p:ext uri="{BB962C8B-B14F-4D97-AF65-F5344CB8AC3E}">
-        <p14:creationId xmlns:p14="http://schemas.microsoft.com/office/powerpoint/2010/main" val="955217236"/>
+        <p14:creationId xmlns:p14="http://schemas.microsoft.com/office/powerpoint/2010/main" val="1857682446"/>
       </p:ext>
     </p:extLst>
   </p:cSld>
@@ -1726,6 +1726,45 @@
           </a:p>
         </p:txBody>
       </p:sp>
+      <p:sp>
+        <p:nvSpPr>
+          <p:cNvPr id="7" name="Text 3"/>
+          <p:cNvSpPr txBox="1"/>
+          <p:nvPr/>
+        </p:nvSpPr>
+        <p:spPr>
+          <a:xfrm>
+            <a:off x="8229600" y="4809744"/>
+            <a:ext cx="640080" cy="256032"/>
+          </a:xfrm>
+          <a:prstGeom prst="rect">
+            <a:avLst/>
+          </a:prstGeom>
+          <a:noFill/>
+          <a:ln/>
+        </p:spPr>
+        <p:txBody>
+          <a:bodyPr wrap="square" lIns="0" tIns="0" rIns="0" bIns="0" rtlCol="0" anchor="ctr"/>
+          <a:lstStyle/>
+          <a:p>
+            <a:pPr marL="0" indent="0" algn="r">
+              <a:buNone/>
+            </a:pPr>
+            <a:r>
+              <a:rPr lang="en-US" sz="1000" b="1" dirty="0">
+                <a:solidFill>
+                  <a:srgbClr val="6B7280"/>
+                </a:solidFill>
+                <a:latin typeface="Arial" pitchFamily="34" charset="0"/>
+                <a:ea typeface="Arial" pitchFamily="34" charset="-122"/>
+                <a:cs typeface="Arial" pitchFamily="34" charset="-120"/>
+              </a:rPr>
+              <a:t>1</a:t>
+            </a:r>
+            <a:endParaRPr lang="en-US" sz="1000" dirty="0"/>
+          </a:p>
+        </p:txBody>
+      </p:sp>
     </p:spTree>
   </p:cSld>
   <p:clrMapOvr>
@@ -1905,39 +1944,14 @@
       </p:pic>
       <p:sp>
         <p:nvSpPr>
-          <p:cNvPr id="6" name="Shape 3"/>
-          <p:cNvSpPr/>
-          <p:nvPr/>
-        </p:nvSpPr>
-        <p:spPr>
-          <a:xfrm>
-            <a:off x="0" y="4846320"/>
-            <a:ext cx="9144000" cy="297180"/>
-          </a:xfrm>
-          <a:prstGeom prst="rect">
-            <a:avLst/>
-          </a:prstGeom>
-          <a:solidFill>
-            <a:srgbClr val="0070C0"/>
-          </a:solidFill>
-          <a:ln w="12700">
-            <a:solidFill>
-              <a:srgbClr val="0070C0"/>
-            </a:solidFill>
-            <a:prstDash val="solid"/>
-          </a:ln>
-        </p:spPr>
-      </p:sp>
-      <p:sp>
-        <p:nvSpPr>
-          <p:cNvPr id="7" name="Text 4"/>
-          <p:cNvSpPr txBox="1"/>
-          <p:nvPr/>
-        </p:nvSpPr>
-        <p:spPr>
-          <a:xfrm>
-            <a:off x="0" y="4846320"/>
-            <a:ext cx="9144000" cy="297180"/>
+          <p:cNvPr id="6" name="Text 3"/>
+          <p:cNvSpPr txBox="1"/>
+          <p:nvPr/>
+        </p:nvSpPr>
+        <p:spPr>
+          <a:xfrm>
+            <a:off x="8229600" y="4809744"/>
+            <a:ext cx="640080" cy="256032"/>
           </a:xfrm>
           <a:prstGeom prst="rect">
             <a:avLst/>
@@ -1949,52 +1963,13 @@
           <a:bodyPr wrap="square" lIns="0" tIns="0" rIns="0" bIns="0" rtlCol="0" anchor="ctr"/>
           <a:lstStyle/>
           <a:p>
-            <a:pPr marL="0" indent="0" algn="ctr">
-              <a:buNone/>
-            </a:pPr>
-            <a:r>
-              <a:rPr lang="en-US" sz="900" dirty="0">
-                <a:solidFill>
-                  <a:srgbClr val="FFFFFF"/>
-                </a:solidFill>
-                <a:latin typeface="Arial" pitchFamily="34" charset="0"/>
-                <a:ea typeface="Arial" pitchFamily="34" charset="-122"/>
-                <a:cs typeface="Arial" pitchFamily="34" charset="-120"/>
-              </a:rPr>
-              <a:t>@SIH Idea submission- Template</a:t>
-            </a:r>
-            <a:endParaRPr lang="en-US" sz="900" dirty="0"/>
-          </a:p>
-        </p:txBody>
-      </p:sp>
-      <p:sp>
-        <p:nvSpPr>
-          <p:cNvPr id="8" name="Text 5"/>
-          <p:cNvSpPr txBox="1"/>
-          <p:nvPr/>
-        </p:nvSpPr>
-        <p:spPr>
-          <a:xfrm>
-            <a:off x="8046720" y="4846320"/>
-            <a:ext cx="822960" cy="297180"/>
-          </a:xfrm>
-          <a:prstGeom prst="rect">
-            <a:avLst/>
-          </a:prstGeom>
-          <a:noFill/>
-          <a:ln/>
-        </p:spPr>
-        <p:txBody>
-          <a:bodyPr wrap="square" lIns="0" tIns="0" rIns="0" bIns="0" rtlCol="0" anchor="ctr"/>
-          <a:lstStyle/>
-          <a:p>
             <a:pPr marL="0" indent="0" algn="r">
               <a:buNone/>
             </a:pPr>
             <a:r>
-              <a:rPr lang="en-US" sz="900" b="1" dirty="0">
-                <a:solidFill>
-                  <a:srgbClr val="FFFFFF"/>
+              <a:rPr lang="en-US" sz="1000" b="1" dirty="0">
+                <a:solidFill>
+                  <a:srgbClr val="6B7280"/>
                 </a:solidFill>
                 <a:latin typeface="Arial" pitchFamily="34" charset="0"/>
                 <a:ea typeface="Arial" pitchFamily="34" charset="-122"/>
@@ -2002,13 +1977,13 @@
               </a:rPr>
               <a:t>2</a:t>
             </a:r>
-            <a:endParaRPr lang="en-US" sz="900" dirty="0"/>
-          </a:p>
-        </p:txBody>
-      </p:sp>
-      <p:sp>
-        <p:nvSpPr>
-          <p:cNvPr id="9" name="Shape 6"/>
+            <a:endParaRPr lang="en-US" sz="1000" dirty="0"/>
+          </a:p>
+        </p:txBody>
+      </p:sp>
+      <p:sp>
+        <p:nvSpPr>
+          <p:cNvPr id="7" name="Shape 4"/>
           <p:cNvSpPr/>
           <p:nvPr/>
         </p:nvSpPr>
@@ -2035,7 +2010,7 @@
       </p:sp>
       <p:sp>
         <p:nvSpPr>
-          <p:cNvPr id="10" name="Shape 7"/>
+          <p:cNvPr id="8" name="Shape 5"/>
           <p:cNvSpPr/>
           <p:nvPr/>
         </p:nvSpPr>
@@ -2062,7 +2037,7 @@
       </p:sp>
       <p:sp>
         <p:nvSpPr>
-          <p:cNvPr id="11" name="Text 8"/>
+          <p:cNvPr id="9" name="Text 6"/>
           <p:cNvSpPr txBox="1"/>
           <p:nvPr/>
         </p:nvSpPr>
@@ -2112,7 +2087,7 @@
       </p:sp>
       <p:sp>
         <p:nvSpPr>
-          <p:cNvPr id="12" name="Shape 9"/>
+          <p:cNvPr id="10" name="Shape 7"/>
           <p:cNvSpPr/>
           <p:nvPr/>
         </p:nvSpPr>
@@ -2139,7 +2114,7 @@
       </p:sp>
       <p:sp>
         <p:nvSpPr>
-          <p:cNvPr id="13" name="Shape 10"/>
+          <p:cNvPr id="11" name="Shape 8"/>
           <p:cNvSpPr/>
           <p:nvPr/>
         </p:nvSpPr>
@@ -2166,7 +2141,7 @@
       </p:sp>
       <p:sp>
         <p:nvSpPr>
-          <p:cNvPr id="14" name="Text 11"/>
+          <p:cNvPr id="12" name="Text 9"/>
           <p:cNvSpPr txBox="1"/>
           <p:nvPr/>
         </p:nvSpPr>
@@ -2216,7 +2191,7 @@
       </p:sp>
       <p:sp>
         <p:nvSpPr>
-          <p:cNvPr id="15" name="Shape 12"/>
+          <p:cNvPr id="13" name="Shape 10"/>
           <p:cNvSpPr/>
           <p:nvPr/>
         </p:nvSpPr>
@@ -2243,7 +2218,7 @@
       </p:sp>
       <p:sp>
         <p:nvSpPr>
-          <p:cNvPr id="16" name="Shape 13"/>
+          <p:cNvPr id="14" name="Shape 11"/>
           <p:cNvSpPr/>
           <p:nvPr/>
         </p:nvSpPr>
@@ -2270,7 +2245,7 @@
       </p:sp>
       <p:sp>
         <p:nvSpPr>
-          <p:cNvPr id="17" name="Text 14"/>
+          <p:cNvPr id="15" name="Text 12"/>
           <p:cNvSpPr txBox="1"/>
           <p:nvPr/>
         </p:nvSpPr>
@@ -2320,7 +2295,7 @@
       </p:sp>
       <p:sp>
         <p:nvSpPr>
-          <p:cNvPr id="18" name="Shape 15"/>
+          <p:cNvPr id="16" name="Shape 13"/>
           <p:cNvSpPr/>
           <p:nvPr/>
         </p:nvSpPr>
@@ -2345,7 +2320,7 @@
       </p:sp>
       <p:sp>
         <p:nvSpPr>
-          <p:cNvPr id="19" name="Text 16"/>
+          <p:cNvPr id="17" name="Text 14"/>
           <p:cNvSpPr txBox="1"/>
           <p:nvPr/>
         </p:nvSpPr>
@@ -2415,7 +2390,7 @@
       </p:sp>
       <p:sp>
         <p:nvSpPr>
-          <p:cNvPr id="20" name="Text 17"/>
+          <p:cNvPr id="18" name="Text 15"/>
           <p:cNvSpPr txBox="1"/>
           <p:nvPr/>
         </p:nvSpPr>
@@ -2454,7 +2429,7 @@
       </p:sp>
       <p:sp>
         <p:nvSpPr>
-          <p:cNvPr id="21" name="Shape 18"/>
+          <p:cNvPr id="19" name="Shape 16"/>
           <p:cNvSpPr/>
           <p:nvPr/>
         </p:nvSpPr>
@@ -2478,7 +2453,7 @@
       </p:sp>
       <p:sp>
         <p:nvSpPr>
-          <p:cNvPr id="22" name="Text 19"/>
+          <p:cNvPr id="20" name="Text 17"/>
           <p:cNvSpPr txBox="1"/>
           <p:nvPr/>
         </p:nvSpPr>
@@ -2517,7 +2492,7 @@
       </p:sp>
       <p:sp>
         <p:nvSpPr>
-          <p:cNvPr id="23" name="Shape 20"/>
+          <p:cNvPr id="21" name="Shape 18"/>
           <p:cNvSpPr/>
           <p:nvPr/>
         </p:nvSpPr>
@@ -2542,7 +2517,7 @@
       </p:sp>
       <p:sp>
         <p:nvSpPr>
-          <p:cNvPr id="24" name="Shape 21"/>
+          <p:cNvPr id="22" name="Shape 19"/>
           <p:cNvSpPr/>
           <p:nvPr/>
         </p:nvSpPr>
@@ -2569,7 +2544,7 @@
       </p:sp>
       <p:sp>
         <p:nvSpPr>
-          <p:cNvPr id="25" name="Text 22"/>
+          <p:cNvPr id="23" name="Text 20"/>
           <p:cNvSpPr txBox="1"/>
           <p:nvPr/>
         </p:nvSpPr>
@@ -2608,7 +2583,7 @@
       </p:sp>
       <p:sp>
         <p:nvSpPr>
-          <p:cNvPr id="26" name="Text 23"/>
+          <p:cNvPr id="24" name="Text 21"/>
           <p:cNvSpPr txBox="1"/>
           <p:nvPr/>
         </p:nvSpPr>
@@ -2647,7 +2622,7 @@
       </p:sp>
       <p:sp>
         <p:nvSpPr>
-          <p:cNvPr id="27" name="Shape 24"/>
+          <p:cNvPr id="25" name="Shape 22"/>
           <p:cNvSpPr/>
           <p:nvPr/>
         </p:nvSpPr>
@@ -2674,7 +2649,7 @@
       </p:sp>
       <p:sp>
         <p:nvSpPr>
-          <p:cNvPr id="28" name="Text 25"/>
+          <p:cNvPr id="26" name="Text 23"/>
           <p:cNvSpPr txBox="1"/>
           <p:nvPr/>
         </p:nvSpPr>
@@ -2713,7 +2688,7 @@
       </p:sp>
       <p:sp>
         <p:nvSpPr>
-          <p:cNvPr id="29" name="Text 26"/>
+          <p:cNvPr id="27" name="Text 24"/>
           <p:cNvSpPr txBox="1"/>
           <p:nvPr/>
         </p:nvSpPr>
@@ -2752,7 +2727,7 @@
       </p:sp>
       <p:sp>
         <p:nvSpPr>
-          <p:cNvPr id="30" name="Shape 27"/>
+          <p:cNvPr id="28" name="Shape 25"/>
           <p:cNvSpPr/>
           <p:nvPr/>
         </p:nvSpPr>
@@ -2779,7 +2754,7 @@
       </p:sp>
       <p:sp>
         <p:nvSpPr>
-          <p:cNvPr id="31" name="Text 28"/>
+          <p:cNvPr id="29" name="Text 26"/>
           <p:cNvSpPr txBox="1"/>
           <p:nvPr/>
         </p:nvSpPr>
@@ -2818,7 +2793,7 @@
       </p:sp>
       <p:sp>
         <p:nvSpPr>
-          <p:cNvPr id="32" name="Text 29"/>
+          <p:cNvPr id="30" name="Text 27"/>
           <p:cNvSpPr txBox="1"/>
           <p:nvPr/>
         </p:nvSpPr>
@@ -2857,7 +2832,7 @@
       </p:sp>
       <p:sp>
         <p:nvSpPr>
-          <p:cNvPr id="33" name="Shape 30"/>
+          <p:cNvPr id="31" name="Shape 28"/>
           <p:cNvSpPr/>
           <p:nvPr/>
         </p:nvSpPr>
@@ -2884,7 +2859,7 @@
       </p:sp>
       <p:sp>
         <p:nvSpPr>
-          <p:cNvPr id="34" name="Text 31"/>
+          <p:cNvPr id="32" name="Text 29"/>
           <p:cNvSpPr txBox="1"/>
           <p:nvPr/>
         </p:nvSpPr>
@@ -2923,7 +2898,7 @@
       </p:sp>
       <p:sp>
         <p:nvSpPr>
-          <p:cNvPr id="35" name="Text 32"/>
+          <p:cNvPr id="33" name="Text 30"/>
           <p:cNvSpPr txBox="1"/>
           <p:nvPr/>
         </p:nvSpPr>
@@ -2962,7 +2937,7 @@
       </p:sp>
       <p:sp>
         <p:nvSpPr>
-          <p:cNvPr id="36" name="Text 33"/>
+          <p:cNvPr id="34" name="Text 31"/>
           <p:cNvSpPr txBox="1"/>
           <p:nvPr/>
         </p:nvSpPr>
@@ -3001,7 +2976,7 @@
       </p:sp>
       <p:sp>
         <p:nvSpPr>
-          <p:cNvPr id="37" name="Text 34"/>
+          <p:cNvPr id="35" name="Text 32"/>
           <p:cNvSpPr txBox="1"/>
           <p:nvPr/>
         </p:nvSpPr>
@@ -3040,7 +3015,7 @@
       </p:sp>
       <p:sp>
         <p:nvSpPr>
-          <p:cNvPr id="38" name="Text 35"/>
+          <p:cNvPr id="36" name="Text 33"/>
           <p:cNvSpPr txBox="1"/>
           <p:nvPr/>
         </p:nvSpPr>
@@ -3079,7 +3054,7 @@
       </p:sp>
       <p:sp>
         <p:nvSpPr>
-          <p:cNvPr id="39" name="Shape 36"/>
+          <p:cNvPr id="37" name="Shape 34"/>
           <p:cNvSpPr/>
           <p:nvPr/>
         </p:nvSpPr>
@@ -3113,7 +3088,7 @@
       </p:sp>
       <p:sp>
         <p:nvSpPr>
-          <p:cNvPr id="40" name="Text 37"/>
+          <p:cNvPr id="38" name="Text 35"/>
           <p:cNvSpPr txBox="1"/>
           <p:nvPr/>
         </p:nvSpPr>
@@ -3152,7 +3127,7 @@
       </p:sp>
       <p:sp>
         <p:nvSpPr>
-          <p:cNvPr id="41" name="Shape 38"/>
+          <p:cNvPr id="39" name="Shape 36"/>
           <p:cNvSpPr/>
           <p:nvPr/>
         </p:nvSpPr>
@@ -3177,7 +3152,7 @@
       </p:sp>
       <p:sp>
         <p:nvSpPr>
-          <p:cNvPr id="42" name="Shape 39"/>
+          <p:cNvPr id="40" name="Shape 37"/>
           <p:cNvSpPr/>
           <p:nvPr/>
         </p:nvSpPr>
@@ -3211,7 +3186,7 @@
       </p:sp>
       <p:sp>
         <p:nvSpPr>
-          <p:cNvPr id="43" name="Text 40"/>
+          <p:cNvPr id="41" name="Text 38"/>
           <p:cNvSpPr txBox="1"/>
           <p:nvPr/>
         </p:nvSpPr>
@@ -3250,7 +3225,7 @@
       </p:sp>
       <p:sp>
         <p:nvSpPr>
-          <p:cNvPr id="44" name="Shape 41"/>
+          <p:cNvPr id="42" name="Shape 39"/>
           <p:cNvSpPr/>
           <p:nvPr/>
         </p:nvSpPr>
@@ -3284,7 +3259,7 @@
       </p:sp>
       <p:sp>
         <p:nvSpPr>
-          <p:cNvPr id="45" name="Text 42"/>
+          <p:cNvPr id="43" name="Text 40"/>
           <p:cNvSpPr txBox="1"/>
           <p:nvPr/>
         </p:nvSpPr>
@@ -3323,7 +3298,7 @@
       </p:sp>
       <p:sp>
         <p:nvSpPr>
-          <p:cNvPr id="46" name="Shape 43"/>
+          <p:cNvPr id="44" name="Shape 41"/>
           <p:cNvSpPr/>
           <p:nvPr/>
         </p:nvSpPr>
@@ -3348,7 +3323,7 @@
       </p:sp>
       <p:sp>
         <p:nvSpPr>
-          <p:cNvPr id="47" name="Shape 44"/>
+          <p:cNvPr id="45" name="Shape 42"/>
           <p:cNvSpPr/>
           <p:nvPr/>
         </p:nvSpPr>
@@ -3382,7 +3357,7 @@
       </p:sp>
       <p:sp>
         <p:nvSpPr>
-          <p:cNvPr id="48" name="Text 45"/>
+          <p:cNvPr id="46" name="Text 43"/>
           <p:cNvSpPr txBox="1"/>
           <p:nvPr/>
         </p:nvSpPr>
@@ -3421,7 +3396,7 @@
       </p:sp>
       <p:sp>
         <p:nvSpPr>
-          <p:cNvPr id="49" name="Shape 46"/>
+          <p:cNvPr id="47" name="Shape 44"/>
           <p:cNvSpPr/>
           <p:nvPr/>
         </p:nvSpPr>
@@ -3455,7 +3430,7 @@
       </p:sp>
       <p:sp>
         <p:nvSpPr>
-          <p:cNvPr id="50" name="Text 47"/>
+          <p:cNvPr id="48" name="Text 45"/>
           <p:cNvSpPr txBox="1"/>
           <p:nvPr/>
         </p:nvSpPr>
@@ -3494,7 +3469,7 @@
       </p:sp>
       <p:sp>
         <p:nvSpPr>
-          <p:cNvPr id="51" name="Shape 48"/>
+          <p:cNvPr id="49" name="Shape 46"/>
           <p:cNvSpPr/>
           <p:nvPr/>
         </p:nvSpPr>
@@ -3519,7 +3494,7 @@
       </p:sp>
       <p:sp>
         <p:nvSpPr>
-          <p:cNvPr id="52" name="Shape 49"/>
+          <p:cNvPr id="50" name="Shape 47"/>
           <p:cNvSpPr/>
           <p:nvPr/>
         </p:nvSpPr>
@@ -3553,7 +3528,7 @@
       </p:sp>
       <p:sp>
         <p:nvSpPr>
-          <p:cNvPr id="53" name="Text 50"/>
+          <p:cNvPr id="51" name="Text 48"/>
           <p:cNvSpPr txBox="1"/>
           <p:nvPr/>
         </p:nvSpPr>
@@ -3592,7 +3567,7 @@
       </p:sp>
       <p:sp>
         <p:nvSpPr>
-          <p:cNvPr id="54" name="Shape 51"/>
+          <p:cNvPr id="52" name="Shape 49"/>
           <p:cNvSpPr/>
           <p:nvPr/>
         </p:nvSpPr>
@@ -3626,7 +3601,7 @@
       </p:sp>
       <p:sp>
         <p:nvSpPr>
-          <p:cNvPr id="55" name="Text 52"/>
+          <p:cNvPr id="53" name="Text 50"/>
           <p:cNvSpPr txBox="1"/>
           <p:nvPr/>
         </p:nvSpPr>
@@ -3665,7 +3640,7 @@
       </p:sp>
       <p:sp>
         <p:nvSpPr>
-          <p:cNvPr id="56" name="Shape 53"/>
+          <p:cNvPr id="54" name="Shape 51"/>
           <p:cNvSpPr/>
           <p:nvPr/>
         </p:nvSpPr>
@@ -3690,7 +3665,7 @@
       </p:sp>
       <p:sp>
         <p:nvSpPr>
-          <p:cNvPr id="57" name="Shape 54"/>
+          <p:cNvPr id="55" name="Shape 52"/>
           <p:cNvSpPr/>
           <p:nvPr/>
         </p:nvSpPr>
@@ -3724,7 +3699,7 @@
       </p:sp>
       <p:sp>
         <p:nvSpPr>
-          <p:cNvPr id="58" name="Text 55"/>
+          <p:cNvPr id="56" name="Text 53"/>
           <p:cNvSpPr txBox="1"/>
           <p:nvPr/>
         </p:nvSpPr>
@@ -3763,7 +3738,7 @@
       </p:sp>
       <p:pic>
         <p:nvPicPr>
-          <p:cNvPr id="59" name="Image 1" descr="preencoded.png"/>
+          <p:cNvPr id="57" name="Image 1" descr="preencoded.png"/>
           <p:cNvPicPr>
             <a:picLocks noChangeAspect="1"/>
           </p:cNvPicPr>
@@ -3771,13 +3746,13 @@
         </p:nvPicPr>
         <p:blipFill>
           <a:blip r:embed="rId6"/>
-          <a:srcRect t="15789" b="-15789"/>
+          <a:srcRect t="12000" b="-12000"/>
           <a:stretch/>
         </p:blipFill>
         <p:spPr>
           <a:xfrm>
             <a:off x="6400800" y="3794760"/>
-            <a:ext cx="2542032" cy="868680"/>
+            <a:ext cx="2542032" cy="914400"/>
           </a:xfrm>
           <a:prstGeom prst="rect">
             <a:avLst/>
@@ -3786,14 +3761,14 @@
       </p:pic>
       <p:sp>
         <p:nvSpPr>
-          <p:cNvPr id="60" name="Text 56"/>
-          <p:cNvSpPr txBox="1"/>
-          <p:nvPr/>
-        </p:nvSpPr>
-        <p:spPr>
-          <a:xfrm>
-            <a:off x="6400800" y="4663440"/>
-            <a:ext cx="2542032" cy="146304"/>
+          <p:cNvPr id="58" name="Text 54"/>
+          <p:cNvSpPr txBox="1"/>
+          <p:nvPr/>
+        </p:nvSpPr>
+        <p:spPr>
+          <a:xfrm>
+            <a:off x="6400800" y="4736592"/>
+            <a:ext cx="2542032" cy="164592"/>
           </a:xfrm>
           <a:prstGeom prst="rect">
             <a:avLst/>
@@ -3985,110 +3960,46 @@
       </p:pic>
       <p:sp>
         <p:nvSpPr>
-          <p:cNvPr id="6" name="Shape 3"/>
-          <p:cNvSpPr/>
-          <p:nvPr/>
-        </p:nvSpPr>
-        <p:spPr>
-          <a:xfrm>
-            <a:off x="0" y="4846320"/>
-            <a:ext cx="9144000" cy="297180"/>
-          </a:xfrm>
-          <a:prstGeom prst="rect">
-            <a:avLst/>
-          </a:prstGeom>
-          <a:solidFill>
-            <a:srgbClr val="0070C0"/>
-          </a:solidFill>
-          <a:ln w="12700">
-            <a:solidFill>
-              <a:srgbClr val="0070C0"/>
-            </a:solidFill>
-            <a:prstDash val="solid"/>
-          </a:ln>
-        </p:spPr>
+          <p:cNvPr id="6" name="Text 3"/>
+          <p:cNvSpPr txBox="1"/>
+          <p:nvPr/>
+        </p:nvSpPr>
+        <p:spPr>
+          <a:xfrm>
+            <a:off x="8229600" y="4809744"/>
+            <a:ext cx="640080" cy="256032"/>
+          </a:xfrm>
+          <a:prstGeom prst="rect">
+            <a:avLst/>
+          </a:prstGeom>
+          <a:noFill/>
+          <a:ln/>
+        </p:spPr>
+        <p:txBody>
+          <a:bodyPr wrap="square" lIns="0" tIns="0" rIns="0" bIns="0" rtlCol="0" anchor="ctr"/>
+          <a:lstStyle/>
+          <a:p>
+            <a:pPr marL="0" indent="0" algn="r">
+              <a:buNone/>
+            </a:pPr>
+            <a:r>
+              <a:rPr lang="en-US" sz="1000" b="1" dirty="0">
+                <a:solidFill>
+                  <a:srgbClr val="6B7280"/>
+                </a:solidFill>
+                <a:latin typeface="Arial" pitchFamily="34" charset="0"/>
+                <a:ea typeface="Arial" pitchFamily="34" charset="-122"/>
+                <a:cs typeface="Arial" pitchFamily="34" charset="-120"/>
+              </a:rPr>
+              <a:t>3</a:t>
+            </a:r>
+            <a:endParaRPr lang="en-US" sz="1000" dirty="0"/>
+          </a:p>
+        </p:txBody>
       </p:sp>
       <p:sp>
         <p:nvSpPr>
           <p:cNvPr id="7" name="Text 4"/>
-          <p:cNvSpPr txBox="1"/>
-          <p:nvPr/>
-        </p:nvSpPr>
-        <p:spPr>
-          <a:xfrm>
-            <a:off x="0" y="4846320"/>
-            <a:ext cx="9144000" cy="297180"/>
-          </a:xfrm>
-          <a:prstGeom prst="rect">
-            <a:avLst/>
-          </a:prstGeom>
-          <a:noFill/>
-          <a:ln/>
-        </p:spPr>
-        <p:txBody>
-          <a:bodyPr wrap="square" lIns="0" tIns="0" rIns="0" bIns="0" rtlCol="0" anchor="ctr"/>
-          <a:lstStyle/>
-          <a:p>
-            <a:pPr marL="0" indent="0" algn="ctr">
-              <a:buNone/>
-            </a:pPr>
-            <a:r>
-              <a:rPr lang="en-US" sz="900" dirty="0">
-                <a:solidFill>
-                  <a:srgbClr val="FFFFFF"/>
-                </a:solidFill>
-                <a:latin typeface="Arial" pitchFamily="34" charset="0"/>
-                <a:ea typeface="Arial" pitchFamily="34" charset="-122"/>
-                <a:cs typeface="Arial" pitchFamily="34" charset="-120"/>
-              </a:rPr>
-              <a:t>@SIH Idea submission- Template</a:t>
-            </a:r>
-            <a:endParaRPr lang="en-US" sz="900" dirty="0"/>
-          </a:p>
-        </p:txBody>
-      </p:sp>
-      <p:sp>
-        <p:nvSpPr>
-          <p:cNvPr id="8" name="Text 5"/>
-          <p:cNvSpPr txBox="1"/>
-          <p:nvPr/>
-        </p:nvSpPr>
-        <p:spPr>
-          <a:xfrm>
-            <a:off x="8046720" y="4846320"/>
-            <a:ext cx="822960" cy="297180"/>
-          </a:xfrm>
-          <a:prstGeom prst="rect">
-            <a:avLst/>
-          </a:prstGeom>
-          <a:noFill/>
-          <a:ln/>
-        </p:spPr>
-        <p:txBody>
-          <a:bodyPr wrap="square" lIns="0" tIns="0" rIns="0" bIns="0" rtlCol="0" anchor="ctr"/>
-          <a:lstStyle/>
-          <a:p>
-            <a:pPr marL="0" indent="0" algn="r">
-              <a:buNone/>
-            </a:pPr>
-            <a:r>
-              <a:rPr lang="en-US" sz="900" b="1" dirty="0">
-                <a:solidFill>
-                  <a:srgbClr val="FFFFFF"/>
-                </a:solidFill>
-                <a:latin typeface="Arial" pitchFamily="34" charset="0"/>
-                <a:ea typeface="Arial" pitchFamily="34" charset="-122"/>
-                <a:cs typeface="Arial" pitchFamily="34" charset="-120"/>
-              </a:rPr>
-              <a:t>3</a:t>
-            </a:r>
-            <a:endParaRPr lang="en-US" sz="900" dirty="0"/>
-          </a:p>
-        </p:txBody>
-      </p:sp>
-      <p:sp>
-        <p:nvSpPr>
-          <p:cNvPr id="9" name="Text 6"/>
           <p:cNvSpPr txBox="1"/>
           <p:nvPr/>
         </p:nvSpPr>
@@ -4144,7 +4055,7 @@
       </p:sp>
       <p:sp>
         <p:nvSpPr>
-          <p:cNvPr id="10" name="Shape 7"/>
+          <p:cNvPr id="8" name="Shape 5"/>
           <p:cNvSpPr/>
           <p:nvPr/>
         </p:nvSpPr>
@@ -4169,7 +4080,7 @@
       </p:sp>
       <p:sp>
         <p:nvSpPr>
-          <p:cNvPr id="11" name="Shape 8"/>
+          <p:cNvPr id="9" name="Shape 6"/>
           <p:cNvSpPr/>
           <p:nvPr/>
         </p:nvSpPr>
@@ -4194,7 +4105,7 @@
       </p:sp>
       <p:sp>
         <p:nvSpPr>
-          <p:cNvPr id="12" name="Text 9"/>
+          <p:cNvPr id="10" name="Text 7"/>
           <p:cNvSpPr txBox="1"/>
           <p:nvPr/>
         </p:nvSpPr>
@@ -4233,7 +4144,7 @@
       </p:sp>
       <p:sp>
         <p:nvSpPr>
-          <p:cNvPr id="13" name="Text 10"/>
+          <p:cNvPr id="11" name="Text 8"/>
           <p:cNvSpPr txBox="1"/>
           <p:nvPr/>
         </p:nvSpPr>
@@ -4272,7 +4183,7 @@
       </p:sp>
       <p:sp>
         <p:nvSpPr>
-          <p:cNvPr id="14" name="Text 11"/>
+          <p:cNvPr id="12" name="Text 9"/>
           <p:cNvSpPr txBox="1"/>
           <p:nvPr/>
         </p:nvSpPr>
@@ -4311,7 +4222,7 @@
       </p:sp>
       <p:sp>
         <p:nvSpPr>
-          <p:cNvPr id="15" name="Shape 12"/>
+          <p:cNvPr id="13" name="Shape 10"/>
           <p:cNvSpPr/>
           <p:nvPr/>
         </p:nvSpPr>
@@ -4336,7 +4247,7 @@
       </p:sp>
       <p:sp>
         <p:nvSpPr>
-          <p:cNvPr id="16" name="Text 13"/>
+          <p:cNvPr id="14" name="Text 11"/>
           <p:cNvSpPr txBox="1"/>
           <p:nvPr/>
         </p:nvSpPr>
@@ -4375,7 +4286,7 @@
       </p:sp>
       <p:sp>
         <p:nvSpPr>
-          <p:cNvPr id="17" name="Text 14"/>
+          <p:cNvPr id="15" name="Text 12"/>
           <p:cNvSpPr txBox="1"/>
           <p:nvPr/>
         </p:nvSpPr>
@@ -4414,7 +4325,7 @@
       </p:sp>
       <p:sp>
         <p:nvSpPr>
-          <p:cNvPr id="18" name="Text 15"/>
+          <p:cNvPr id="16" name="Text 13"/>
           <p:cNvSpPr txBox="1"/>
           <p:nvPr/>
         </p:nvSpPr>
@@ -4453,7 +4364,7 @@
       </p:sp>
       <p:sp>
         <p:nvSpPr>
-          <p:cNvPr id="19" name="Shape 16"/>
+          <p:cNvPr id="17" name="Shape 14"/>
           <p:cNvSpPr/>
           <p:nvPr/>
         </p:nvSpPr>
@@ -4478,7 +4389,7 @@
       </p:sp>
       <p:sp>
         <p:nvSpPr>
-          <p:cNvPr id="20" name="Text 17"/>
+          <p:cNvPr id="18" name="Text 15"/>
           <p:cNvSpPr txBox="1"/>
           <p:nvPr/>
         </p:nvSpPr>
@@ -4517,7 +4428,7 @@
       </p:sp>
       <p:sp>
         <p:nvSpPr>
-          <p:cNvPr id="21" name="Text 18"/>
+          <p:cNvPr id="19" name="Text 16"/>
           <p:cNvSpPr txBox="1"/>
           <p:nvPr/>
         </p:nvSpPr>
@@ -4556,7 +4467,7 @@
       </p:sp>
       <p:sp>
         <p:nvSpPr>
-          <p:cNvPr id="22" name="Text 19"/>
+          <p:cNvPr id="20" name="Text 17"/>
           <p:cNvSpPr txBox="1"/>
           <p:nvPr/>
         </p:nvSpPr>
@@ -4595,7 +4506,7 @@
       </p:sp>
       <p:sp>
         <p:nvSpPr>
-          <p:cNvPr id="23" name="Shape 20"/>
+          <p:cNvPr id="21" name="Shape 18"/>
           <p:cNvSpPr/>
           <p:nvPr/>
         </p:nvSpPr>
@@ -4620,7 +4531,7 @@
       </p:sp>
       <p:sp>
         <p:nvSpPr>
-          <p:cNvPr id="24" name="Text 21"/>
+          <p:cNvPr id="22" name="Text 19"/>
           <p:cNvSpPr txBox="1"/>
           <p:nvPr/>
         </p:nvSpPr>
@@ -4659,7 +4570,7 @@
       </p:sp>
       <p:sp>
         <p:nvSpPr>
-          <p:cNvPr id="25" name="Text 22"/>
+          <p:cNvPr id="23" name="Text 20"/>
           <p:cNvSpPr txBox="1"/>
           <p:nvPr/>
         </p:nvSpPr>
@@ -4698,7 +4609,7 @@
       </p:sp>
       <p:sp>
         <p:nvSpPr>
-          <p:cNvPr id="26" name="Text 23"/>
+          <p:cNvPr id="24" name="Text 21"/>
           <p:cNvSpPr txBox="1"/>
           <p:nvPr/>
         </p:nvSpPr>
@@ -4737,7 +4648,7 @@
       </p:sp>
       <p:sp>
         <p:nvSpPr>
-          <p:cNvPr id="27" name="Shape 24"/>
+          <p:cNvPr id="25" name="Shape 22"/>
           <p:cNvSpPr/>
           <p:nvPr/>
         </p:nvSpPr>
@@ -4762,7 +4673,7 @@
       </p:sp>
       <p:sp>
         <p:nvSpPr>
-          <p:cNvPr id="28" name="Text 25"/>
+          <p:cNvPr id="26" name="Text 23"/>
           <p:cNvSpPr txBox="1"/>
           <p:nvPr/>
         </p:nvSpPr>
@@ -4801,7 +4712,7 @@
       </p:sp>
       <p:sp>
         <p:nvSpPr>
-          <p:cNvPr id="29" name="Text 26"/>
+          <p:cNvPr id="27" name="Text 24"/>
           <p:cNvSpPr txBox="1"/>
           <p:nvPr/>
         </p:nvSpPr>
@@ -4840,7 +4751,7 @@
       </p:sp>
       <p:sp>
         <p:nvSpPr>
-          <p:cNvPr id="30" name="Text 27"/>
+          <p:cNvPr id="28" name="Text 25"/>
           <p:cNvSpPr txBox="1"/>
           <p:nvPr/>
         </p:nvSpPr>
@@ -4879,7 +4790,7 @@
       </p:sp>
       <p:sp>
         <p:nvSpPr>
-          <p:cNvPr id="31" name="Shape 28"/>
+          <p:cNvPr id="29" name="Shape 26"/>
           <p:cNvSpPr/>
           <p:nvPr/>
         </p:nvSpPr>
@@ -4904,7 +4815,7 @@
       </p:sp>
       <p:sp>
         <p:nvSpPr>
-          <p:cNvPr id="32" name="Text 29"/>
+          <p:cNvPr id="30" name="Text 27"/>
           <p:cNvSpPr txBox="1"/>
           <p:nvPr/>
         </p:nvSpPr>
@@ -4943,7 +4854,7 @@
       </p:sp>
       <p:sp>
         <p:nvSpPr>
-          <p:cNvPr id="33" name="Text 30"/>
+          <p:cNvPr id="31" name="Text 28"/>
           <p:cNvSpPr txBox="1"/>
           <p:nvPr/>
         </p:nvSpPr>
@@ -4982,7 +4893,7 @@
       </p:sp>
       <p:sp>
         <p:nvSpPr>
-          <p:cNvPr id="34" name="Text 31"/>
+          <p:cNvPr id="32" name="Text 29"/>
           <p:cNvSpPr txBox="1"/>
           <p:nvPr/>
         </p:nvSpPr>
@@ -5021,7 +4932,7 @@
       </p:sp>
       <p:sp>
         <p:nvSpPr>
-          <p:cNvPr id="35" name="Shape 32"/>
+          <p:cNvPr id="33" name="Shape 30"/>
           <p:cNvSpPr/>
           <p:nvPr/>
         </p:nvSpPr>
@@ -5046,7 +4957,7 @@
       </p:sp>
       <p:sp>
         <p:nvSpPr>
-          <p:cNvPr id="36" name="Text 33"/>
+          <p:cNvPr id="34" name="Text 31"/>
           <p:cNvSpPr txBox="1"/>
           <p:nvPr/>
         </p:nvSpPr>
@@ -5116,7 +5027,7 @@
       </p:sp>
       <p:sp>
         <p:nvSpPr>
-          <p:cNvPr id="37" name="Text 34"/>
+          <p:cNvPr id="35" name="Text 32"/>
           <p:cNvSpPr txBox="1"/>
           <p:nvPr/>
         </p:nvSpPr>
@@ -5172,7 +5083,7 @@
       </p:sp>
       <p:sp>
         <p:nvSpPr>
-          <p:cNvPr id="38" name="Shape 35"/>
+          <p:cNvPr id="36" name="Shape 33"/>
           <p:cNvSpPr/>
           <p:nvPr/>
         </p:nvSpPr>
@@ -5196,7 +5107,7 @@
       </p:sp>
       <p:sp>
         <p:nvSpPr>
-          <p:cNvPr id="39" name="Shape 36"/>
+          <p:cNvPr id="37" name="Shape 34"/>
           <p:cNvSpPr/>
           <p:nvPr/>
         </p:nvSpPr>
@@ -5223,7 +5134,7 @@
       </p:sp>
       <p:sp>
         <p:nvSpPr>
-          <p:cNvPr id="40" name="Shape 37"/>
+          <p:cNvPr id="38" name="Shape 35"/>
           <p:cNvSpPr/>
           <p:nvPr/>
         </p:nvSpPr>
@@ -5248,7 +5159,7 @@
       </p:sp>
       <p:sp>
         <p:nvSpPr>
-          <p:cNvPr id="41" name="Text 38"/>
+          <p:cNvPr id="39" name="Text 36"/>
           <p:cNvSpPr txBox="1"/>
           <p:nvPr/>
         </p:nvSpPr>
@@ -5287,7 +5198,7 @@
       </p:sp>
       <p:sp>
         <p:nvSpPr>
-          <p:cNvPr id="42" name="Text 39"/>
+          <p:cNvPr id="40" name="Text 37"/>
           <p:cNvSpPr txBox="1"/>
           <p:nvPr/>
         </p:nvSpPr>
@@ -5343,7 +5254,7 @@
       </p:sp>
       <p:sp>
         <p:nvSpPr>
-          <p:cNvPr id="43" name="Shape 40"/>
+          <p:cNvPr id="41" name="Shape 38"/>
           <p:cNvSpPr/>
           <p:nvPr/>
         </p:nvSpPr>
@@ -5367,7 +5278,7 @@
       </p:sp>
       <p:sp>
         <p:nvSpPr>
-          <p:cNvPr id="44" name="Shape 41"/>
+          <p:cNvPr id="42" name="Shape 39"/>
           <p:cNvSpPr/>
           <p:nvPr/>
         </p:nvSpPr>
@@ -5392,7 +5303,7 @@
       </p:sp>
       <p:sp>
         <p:nvSpPr>
-          <p:cNvPr id="45" name="Text 42"/>
+          <p:cNvPr id="43" name="Text 40"/>
           <p:cNvSpPr txBox="1"/>
           <p:nvPr/>
         </p:nvSpPr>
@@ -5431,7 +5342,7 @@
       </p:sp>
       <p:sp>
         <p:nvSpPr>
-          <p:cNvPr id="46" name="Text 43"/>
+          <p:cNvPr id="44" name="Text 41"/>
           <p:cNvSpPr txBox="1"/>
           <p:nvPr/>
         </p:nvSpPr>
@@ -5487,7 +5398,7 @@
       </p:sp>
       <p:sp>
         <p:nvSpPr>
-          <p:cNvPr id="47" name="Shape 44"/>
+          <p:cNvPr id="45" name="Shape 42"/>
           <p:cNvSpPr/>
           <p:nvPr/>
         </p:nvSpPr>
@@ -5511,7 +5422,7 @@
       </p:sp>
       <p:sp>
         <p:nvSpPr>
-          <p:cNvPr id="48" name="Shape 45"/>
+          <p:cNvPr id="46" name="Shape 43"/>
           <p:cNvSpPr/>
           <p:nvPr/>
         </p:nvSpPr>
@@ -5536,7 +5447,7 @@
       </p:sp>
       <p:sp>
         <p:nvSpPr>
-          <p:cNvPr id="49" name="Text 46"/>
+          <p:cNvPr id="47" name="Text 44"/>
           <p:cNvSpPr txBox="1"/>
           <p:nvPr/>
         </p:nvSpPr>
@@ -5575,7 +5486,7 @@
       </p:sp>
       <p:sp>
         <p:nvSpPr>
-          <p:cNvPr id="50" name="Text 47"/>
+          <p:cNvPr id="48" name="Text 45"/>
           <p:cNvSpPr txBox="1"/>
           <p:nvPr/>
         </p:nvSpPr>
@@ -5631,7 +5542,7 @@
       </p:sp>
       <p:sp>
         <p:nvSpPr>
-          <p:cNvPr id="51" name="Shape 48"/>
+          <p:cNvPr id="49" name="Shape 46"/>
           <p:cNvSpPr/>
           <p:nvPr/>
         </p:nvSpPr>
@@ -5655,7 +5566,7 @@
       </p:sp>
       <p:sp>
         <p:nvSpPr>
-          <p:cNvPr id="52" name="Shape 49"/>
+          <p:cNvPr id="50" name="Shape 47"/>
           <p:cNvSpPr/>
           <p:nvPr/>
         </p:nvSpPr>
@@ -5680,7 +5591,7 @@
       </p:sp>
       <p:sp>
         <p:nvSpPr>
-          <p:cNvPr id="53" name="Text 50"/>
+          <p:cNvPr id="51" name="Text 48"/>
           <p:cNvSpPr txBox="1"/>
           <p:nvPr/>
         </p:nvSpPr>
@@ -5719,7 +5630,7 @@
       </p:sp>
       <p:sp>
         <p:nvSpPr>
-          <p:cNvPr id="54" name="Text 51"/>
+          <p:cNvPr id="52" name="Text 49"/>
           <p:cNvSpPr txBox="1"/>
           <p:nvPr/>
         </p:nvSpPr>
@@ -5775,7 +5686,7 @@
       </p:sp>
       <p:sp>
         <p:nvSpPr>
-          <p:cNvPr id="55" name="Shape 52"/>
+          <p:cNvPr id="53" name="Shape 50"/>
           <p:cNvSpPr/>
           <p:nvPr/>
         </p:nvSpPr>
@@ -5802,7 +5713,7 @@
       </p:sp>
       <p:sp>
         <p:nvSpPr>
-          <p:cNvPr id="56" name="Text 53"/>
+          <p:cNvPr id="54" name="Text 51"/>
           <p:cNvSpPr txBox="1"/>
           <p:nvPr/>
         </p:nvSpPr>
@@ -5852,7 +5763,7 @@
       </p:sp>
       <p:pic>
         <p:nvPicPr>
-          <p:cNvPr id="57" name="Image 1" descr="preencoded.png"/>
+          <p:cNvPr id="55" name="Image 1" descr="preencoded.png"/>
           <p:cNvPicPr>
             <a:picLocks noChangeAspect="1"/>
           </p:cNvPicPr>
@@ -5876,7 +5787,7 @@
       </p:pic>
       <p:sp>
         <p:nvSpPr>
-          <p:cNvPr id="58" name="Text 54"/>
+          <p:cNvPr id="56" name="Text 52"/>
           <p:cNvSpPr txBox="1"/>
           <p:nvPr/>
         </p:nvSpPr>
@@ -5915,7 +5826,7 @@
       </p:sp>
       <p:sp>
         <p:nvSpPr>
-          <p:cNvPr id="59" name="Text 55"/>
+          <p:cNvPr id="57" name="Text 53"/>
           <p:cNvSpPr txBox="1"/>
           <p:nvPr/>
         </p:nvSpPr>
@@ -5954,7 +5865,7 @@
       </p:sp>
       <p:sp>
         <p:nvSpPr>
-          <p:cNvPr id="60" name="Shape 56"/>
+          <p:cNvPr id="58" name="Shape 54"/>
           <p:cNvSpPr/>
           <p:nvPr/>
         </p:nvSpPr>
@@ -5988,7 +5899,7 @@
       </p:sp>
       <p:sp>
         <p:nvSpPr>
-          <p:cNvPr id="61" name="Shape 57"/>
+          <p:cNvPr id="59" name="Shape 55"/>
           <p:cNvSpPr/>
           <p:nvPr/>
         </p:nvSpPr>
@@ -6013,7 +5924,7 @@
       </p:sp>
       <p:sp>
         <p:nvSpPr>
-          <p:cNvPr id="62" name="Text 58"/>
+          <p:cNvPr id="60" name="Text 56"/>
           <p:cNvSpPr txBox="1"/>
           <p:nvPr/>
         </p:nvSpPr>
@@ -6052,7 +5963,7 @@
       </p:sp>
       <p:sp>
         <p:nvSpPr>
-          <p:cNvPr id="63" name="Shape 59"/>
+          <p:cNvPr id="61" name="Shape 57"/>
           <p:cNvSpPr/>
           <p:nvPr/>
         </p:nvSpPr>
@@ -6074,7 +5985,7 @@
       </p:sp>
       <p:sp>
         <p:nvSpPr>
-          <p:cNvPr id="64" name="Text 60"/>
+          <p:cNvPr id="62" name="Text 58"/>
           <p:cNvSpPr txBox="1"/>
           <p:nvPr/>
         </p:nvSpPr>
@@ -6113,7 +6024,7 @@
       </p:sp>
       <p:sp>
         <p:nvSpPr>
-          <p:cNvPr id="65" name="Text 61"/>
+          <p:cNvPr id="63" name="Text 59"/>
           <p:cNvSpPr txBox="1"/>
           <p:nvPr/>
         </p:nvSpPr>
@@ -6152,7 +6063,7 @@
       </p:sp>
       <p:sp>
         <p:nvSpPr>
-          <p:cNvPr id="66" name="Shape 62"/>
+          <p:cNvPr id="64" name="Shape 60"/>
           <p:cNvSpPr/>
           <p:nvPr/>
         </p:nvSpPr>
@@ -6186,7 +6097,7 @@
       </p:sp>
       <p:sp>
         <p:nvSpPr>
-          <p:cNvPr id="67" name="Shape 63"/>
+          <p:cNvPr id="65" name="Shape 61"/>
           <p:cNvSpPr/>
           <p:nvPr/>
         </p:nvSpPr>
@@ -6211,7 +6122,7 @@
       </p:sp>
       <p:sp>
         <p:nvSpPr>
-          <p:cNvPr id="68" name="Text 64"/>
+          <p:cNvPr id="66" name="Text 62"/>
           <p:cNvSpPr txBox="1"/>
           <p:nvPr/>
         </p:nvSpPr>
@@ -6250,7 +6161,7 @@
       </p:sp>
       <p:sp>
         <p:nvSpPr>
-          <p:cNvPr id="69" name="Shape 65"/>
+          <p:cNvPr id="67" name="Shape 63"/>
           <p:cNvSpPr/>
           <p:nvPr/>
         </p:nvSpPr>
@@ -6272,7 +6183,7 @@
       </p:sp>
       <p:sp>
         <p:nvSpPr>
-          <p:cNvPr id="70" name="Text 66"/>
+          <p:cNvPr id="68" name="Text 64"/>
           <p:cNvSpPr txBox="1"/>
           <p:nvPr/>
         </p:nvSpPr>
@@ -6311,7 +6222,7 @@
       </p:sp>
       <p:sp>
         <p:nvSpPr>
-          <p:cNvPr id="71" name="Text 67"/>
+          <p:cNvPr id="69" name="Text 65"/>
           <p:cNvSpPr txBox="1"/>
           <p:nvPr/>
         </p:nvSpPr>
@@ -6350,7 +6261,7 @@
       </p:sp>
       <p:sp>
         <p:nvSpPr>
-          <p:cNvPr id="72" name="Shape 68"/>
+          <p:cNvPr id="70" name="Shape 66"/>
           <p:cNvSpPr/>
           <p:nvPr/>
         </p:nvSpPr>
@@ -6384,7 +6295,7 @@
       </p:sp>
       <p:sp>
         <p:nvSpPr>
-          <p:cNvPr id="73" name="Shape 69"/>
+          <p:cNvPr id="71" name="Shape 67"/>
           <p:cNvSpPr/>
           <p:nvPr/>
         </p:nvSpPr>
@@ -6409,7 +6320,7 @@
       </p:sp>
       <p:sp>
         <p:nvSpPr>
-          <p:cNvPr id="74" name="Text 70"/>
+          <p:cNvPr id="72" name="Text 68"/>
           <p:cNvSpPr txBox="1"/>
           <p:nvPr/>
         </p:nvSpPr>
@@ -6448,7 +6359,7 @@
       </p:sp>
       <p:sp>
         <p:nvSpPr>
-          <p:cNvPr id="75" name="Shape 71"/>
+          <p:cNvPr id="73" name="Shape 69"/>
           <p:cNvSpPr/>
           <p:nvPr/>
         </p:nvSpPr>
@@ -6470,7 +6381,7 @@
       </p:sp>
       <p:sp>
         <p:nvSpPr>
-          <p:cNvPr id="76" name="Text 72"/>
+          <p:cNvPr id="74" name="Text 70"/>
           <p:cNvSpPr txBox="1"/>
           <p:nvPr/>
         </p:nvSpPr>
@@ -6509,7 +6420,7 @@
       </p:sp>
       <p:sp>
         <p:nvSpPr>
-          <p:cNvPr id="77" name="Text 73"/>
+          <p:cNvPr id="75" name="Text 71"/>
           <p:cNvSpPr txBox="1"/>
           <p:nvPr/>
         </p:nvSpPr>
@@ -6548,7 +6459,7 @@
       </p:sp>
       <p:sp>
         <p:nvSpPr>
-          <p:cNvPr id="78" name="Shape 74"/>
+          <p:cNvPr id="76" name="Shape 72"/>
           <p:cNvSpPr/>
           <p:nvPr/>
         </p:nvSpPr>
@@ -6582,7 +6493,7 @@
       </p:sp>
       <p:sp>
         <p:nvSpPr>
-          <p:cNvPr id="79" name="Shape 75"/>
+          <p:cNvPr id="77" name="Shape 73"/>
           <p:cNvSpPr/>
           <p:nvPr/>
         </p:nvSpPr>
@@ -6607,7 +6518,7 @@
       </p:sp>
       <p:sp>
         <p:nvSpPr>
-          <p:cNvPr id="80" name="Text 76"/>
+          <p:cNvPr id="78" name="Text 74"/>
           <p:cNvSpPr txBox="1"/>
           <p:nvPr/>
         </p:nvSpPr>
@@ -6646,7 +6557,7 @@
       </p:sp>
       <p:sp>
         <p:nvSpPr>
-          <p:cNvPr id="81" name="Shape 77"/>
+          <p:cNvPr id="79" name="Shape 75"/>
           <p:cNvSpPr/>
           <p:nvPr/>
         </p:nvSpPr>
@@ -6668,7 +6579,7 @@
       </p:sp>
       <p:sp>
         <p:nvSpPr>
-          <p:cNvPr id="82" name="Text 78"/>
+          <p:cNvPr id="80" name="Text 76"/>
           <p:cNvSpPr txBox="1"/>
           <p:nvPr/>
         </p:nvSpPr>
@@ -6707,7 +6618,7 @@
       </p:sp>
       <p:sp>
         <p:nvSpPr>
-          <p:cNvPr id="83" name="Text 79"/>
+          <p:cNvPr id="81" name="Text 77"/>
           <p:cNvSpPr txBox="1"/>
           <p:nvPr/>
         </p:nvSpPr>
@@ -6746,7 +6657,7 @@
       </p:sp>
       <p:sp>
         <p:nvSpPr>
-          <p:cNvPr id="84" name="Shape 80"/>
+          <p:cNvPr id="82" name="Shape 78"/>
           <p:cNvSpPr/>
           <p:nvPr/>
         </p:nvSpPr>
@@ -6780,7 +6691,7 @@
       </p:sp>
       <p:sp>
         <p:nvSpPr>
-          <p:cNvPr id="85" name="Shape 81"/>
+          <p:cNvPr id="83" name="Shape 79"/>
           <p:cNvSpPr/>
           <p:nvPr/>
         </p:nvSpPr>
@@ -6805,7 +6716,7 @@
       </p:sp>
       <p:sp>
         <p:nvSpPr>
-          <p:cNvPr id="86" name="Text 82"/>
+          <p:cNvPr id="84" name="Text 80"/>
           <p:cNvSpPr txBox="1"/>
           <p:nvPr/>
         </p:nvSpPr>
@@ -6844,7 +6755,7 @@
       </p:sp>
       <p:sp>
         <p:nvSpPr>
-          <p:cNvPr id="87" name="Shape 83"/>
+          <p:cNvPr id="85" name="Shape 81"/>
           <p:cNvSpPr/>
           <p:nvPr/>
         </p:nvSpPr>
@@ -6866,7 +6777,7 @@
       </p:sp>
       <p:sp>
         <p:nvSpPr>
-          <p:cNvPr id="88" name="Text 84"/>
+          <p:cNvPr id="86" name="Text 82"/>
           <p:cNvSpPr txBox="1"/>
           <p:nvPr/>
         </p:nvSpPr>
@@ -6905,7 +6816,7 @@
       </p:sp>
       <p:sp>
         <p:nvSpPr>
-          <p:cNvPr id="89" name="Text 85"/>
+          <p:cNvPr id="87" name="Text 83"/>
           <p:cNvSpPr txBox="1"/>
           <p:nvPr/>
         </p:nvSpPr>
@@ -7104,39 +7015,14 @@
       </p:pic>
       <p:sp>
         <p:nvSpPr>
-          <p:cNvPr id="6" name="Shape 3"/>
-          <p:cNvSpPr/>
-          <p:nvPr/>
-        </p:nvSpPr>
-        <p:spPr>
-          <a:xfrm>
-            <a:off x="0" y="4846320"/>
-            <a:ext cx="9144000" cy="297180"/>
-          </a:xfrm>
-          <a:prstGeom prst="rect">
-            <a:avLst/>
-          </a:prstGeom>
-          <a:solidFill>
-            <a:srgbClr val="0070C0"/>
-          </a:solidFill>
-          <a:ln w="12700">
-            <a:solidFill>
-              <a:srgbClr val="0070C0"/>
-            </a:solidFill>
-            <a:prstDash val="solid"/>
-          </a:ln>
-        </p:spPr>
-      </p:sp>
-      <p:sp>
-        <p:nvSpPr>
-          <p:cNvPr id="7" name="Text 4"/>
-          <p:cNvSpPr txBox="1"/>
-          <p:nvPr/>
-        </p:nvSpPr>
-        <p:spPr>
-          <a:xfrm>
-            <a:off x="0" y="4846320"/>
-            <a:ext cx="9144000" cy="297180"/>
+          <p:cNvPr id="6" name="Text 3"/>
+          <p:cNvSpPr txBox="1"/>
+          <p:nvPr/>
+        </p:nvSpPr>
+        <p:spPr>
+          <a:xfrm>
+            <a:off x="8229600" y="4809744"/>
+            <a:ext cx="640080" cy="256032"/>
           </a:xfrm>
           <a:prstGeom prst="rect">
             <a:avLst/>
@@ -7148,52 +7034,13 @@
           <a:bodyPr wrap="square" lIns="0" tIns="0" rIns="0" bIns="0" rtlCol="0" anchor="ctr"/>
           <a:lstStyle/>
           <a:p>
-            <a:pPr marL="0" indent="0" algn="ctr">
-              <a:buNone/>
-            </a:pPr>
-            <a:r>
-              <a:rPr lang="en-US" sz="900" dirty="0">
-                <a:solidFill>
-                  <a:srgbClr val="FFFFFF"/>
-                </a:solidFill>
-                <a:latin typeface="Arial" pitchFamily="34" charset="0"/>
-                <a:ea typeface="Arial" pitchFamily="34" charset="-122"/>
-                <a:cs typeface="Arial" pitchFamily="34" charset="-120"/>
-              </a:rPr>
-              <a:t>@SIH Idea submission- Template</a:t>
-            </a:r>
-            <a:endParaRPr lang="en-US" sz="900" dirty="0"/>
-          </a:p>
-        </p:txBody>
-      </p:sp>
-      <p:sp>
-        <p:nvSpPr>
-          <p:cNvPr id="8" name="Text 5"/>
-          <p:cNvSpPr txBox="1"/>
-          <p:nvPr/>
-        </p:nvSpPr>
-        <p:spPr>
-          <a:xfrm>
-            <a:off x="8046720" y="4846320"/>
-            <a:ext cx="822960" cy="297180"/>
-          </a:xfrm>
-          <a:prstGeom prst="rect">
-            <a:avLst/>
-          </a:prstGeom>
-          <a:noFill/>
-          <a:ln/>
-        </p:spPr>
-        <p:txBody>
-          <a:bodyPr wrap="square" lIns="0" tIns="0" rIns="0" bIns="0" rtlCol="0" anchor="ctr"/>
-          <a:lstStyle/>
-          <a:p>
             <a:pPr marL="0" indent="0" algn="r">
               <a:buNone/>
             </a:pPr>
             <a:r>
-              <a:rPr lang="en-US" sz="900" b="1" dirty="0">
-                <a:solidFill>
-                  <a:srgbClr val="FFFFFF"/>
+              <a:rPr lang="en-US" sz="1000" b="1" dirty="0">
+                <a:solidFill>
+                  <a:srgbClr val="6B7280"/>
                 </a:solidFill>
                 <a:latin typeface="Arial" pitchFamily="34" charset="0"/>
                 <a:ea typeface="Arial" pitchFamily="34" charset="-122"/>
@@ -7201,13 +7048,13 @@
               </a:rPr>
               <a:t>4</a:t>
             </a:r>
-            <a:endParaRPr lang="en-US" sz="900" dirty="0"/>
-          </a:p>
-        </p:txBody>
-      </p:sp>
-      <p:sp>
-        <p:nvSpPr>
-          <p:cNvPr id="9" name="Shape 6"/>
+            <a:endParaRPr lang="en-US" sz="1000" dirty="0"/>
+          </a:p>
+        </p:txBody>
+      </p:sp>
+      <p:sp>
+        <p:nvSpPr>
+          <p:cNvPr id="7" name="Shape 4"/>
           <p:cNvSpPr/>
           <p:nvPr/>
         </p:nvSpPr>
@@ -7234,7 +7081,7 @@
       </p:sp>
       <p:sp>
         <p:nvSpPr>
-          <p:cNvPr id="10" name="Shape 7"/>
+          <p:cNvPr id="8" name="Shape 5"/>
           <p:cNvSpPr/>
           <p:nvPr/>
         </p:nvSpPr>
@@ -7261,7 +7108,7 @@
       </p:sp>
       <p:sp>
         <p:nvSpPr>
-          <p:cNvPr id="11" name="Shape 8"/>
+          <p:cNvPr id="9" name="Shape 6"/>
           <p:cNvSpPr/>
           <p:nvPr/>
         </p:nvSpPr>
@@ -7284,7 +7131,7 @@
       </p:sp>
       <p:sp>
         <p:nvSpPr>
-          <p:cNvPr id="12" name="Shape 9"/>
+          <p:cNvPr id="10" name="Shape 7"/>
           <p:cNvSpPr/>
           <p:nvPr/>
         </p:nvSpPr>
@@ -7309,7 +7156,7 @@
       </p:sp>
       <p:sp>
         <p:nvSpPr>
-          <p:cNvPr id="13" name="Text 10"/>
+          <p:cNvPr id="11" name="Text 8"/>
           <p:cNvSpPr txBox="1"/>
           <p:nvPr/>
         </p:nvSpPr>
@@ -7348,7 +7195,7 @@
       </p:sp>
       <p:sp>
         <p:nvSpPr>
-          <p:cNvPr id="14" name="Text 11"/>
+          <p:cNvPr id="12" name="Text 9"/>
           <p:cNvSpPr txBox="1"/>
           <p:nvPr/>
         </p:nvSpPr>
@@ -7398,7 +7245,7 @@
       </p:sp>
       <p:sp>
         <p:nvSpPr>
-          <p:cNvPr id="15" name="Text 12"/>
+          <p:cNvPr id="13" name="Text 10"/>
           <p:cNvSpPr txBox="1"/>
           <p:nvPr/>
         </p:nvSpPr>
@@ -7448,7 +7295,7 @@
       </p:sp>
       <p:sp>
         <p:nvSpPr>
-          <p:cNvPr id="16" name="Text 13"/>
+          <p:cNvPr id="14" name="Text 11"/>
           <p:cNvSpPr txBox="1"/>
           <p:nvPr/>
         </p:nvSpPr>
@@ -7498,7 +7345,7 @@
       </p:sp>
       <p:sp>
         <p:nvSpPr>
-          <p:cNvPr id="17" name="Text 14"/>
+          <p:cNvPr id="15" name="Text 12"/>
           <p:cNvSpPr txBox="1"/>
           <p:nvPr/>
         </p:nvSpPr>
@@ -7548,7 +7395,7 @@
       </p:sp>
       <p:sp>
         <p:nvSpPr>
-          <p:cNvPr id="18" name="Shape 15"/>
+          <p:cNvPr id="16" name="Shape 13"/>
           <p:cNvSpPr/>
           <p:nvPr/>
         </p:nvSpPr>
@@ -7575,7 +7422,7 @@
       </p:sp>
       <p:sp>
         <p:nvSpPr>
-          <p:cNvPr id="19" name="Shape 16"/>
+          <p:cNvPr id="17" name="Shape 14"/>
           <p:cNvSpPr/>
           <p:nvPr/>
         </p:nvSpPr>
@@ -7602,7 +7449,7 @@
       </p:sp>
       <p:sp>
         <p:nvSpPr>
-          <p:cNvPr id="20" name="Shape 17"/>
+          <p:cNvPr id="18" name="Shape 15"/>
           <p:cNvSpPr/>
           <p:nvPr/>
         </p:nvSpPr>
@@ -7625,7 +7472,7 @@
       </p:sp>
       <p:sp>
         <p:nvSpPr>
-          <p:cNvPr id="21" name="Shape 18"/>
+          <p:cNvPr id="19" name="Shape 16"/>
           <p:cNvSpPr/>
           <p:nvPr/>
         </p:nvSpPr>
@@ -7650,7 +7497,7 @@
       </p:sp>
       <p:sp>
         <p:nvSpPr>
-          <p:cNvPr id="22" name="Text 19"/>
+          <p:cNvPr id="20" name="Text 17"/>
           <p:cNvSpPr txBox="1"/>
           <p:nvPr/>
         </p:nvSpPr>
@@ -7689,7 +7536,7 @@
       </p:sp>
       <p:sp>
         <p:nvSpPr>
-          <p:cNvPr id="23" name="Text 20"/>
+          <p:cNvPr id="21" name="Text 18"/>
           <p:cNvSpPr txBox="1"/>
           <p:nvPr/>
         </p:nvSpPr>
@@ -7739,7 +7586,7 @@
       </p:sp>
       <p:sp>
         <p:nvSpPr>
-          <p:cNvPr id="24" name="Text 21"/>
+          <p:cNvPr id="22" name="Text 19"/>
           <p:cNvSpPr txBox="1"/>
           <p:nvPr/>
         </p:nvSpPr>
@@ -7789,7 +7636,7 @@
       </p:sp>
       <p:sp>
         <p:nvSpPr>
-          <p:cNvPr id="25" name="Text 22"/>
+          <p:cNvPr id="23" name="Text 20"/>
           <p:cNvSpPr txBox="1"/>
           <p:nvPr/>
         </p:nvSpPr>
@@ -7839,7 +7686,7 @@
       </p:sp>
       <p:sp>
         <p:nvSpPr>
-          <p:cNvPr id="26" name="Text 23"/>
+          <p:cNvPr id="24" name="Text 21"/>
           <p:cNvSpPr txBox="1"/>
           <p:nvPr/>
         </p:nvSpPr>
@@ -7889,7 +7736,7 @@
       </p:sp>
       <p:sp>
         <p:nvSpPr>
-          <p:cNvPr id="27" name="Shape 24"/>
+          <p:cNvPr id="25" name="Shape 22"/>
           <p:cNvSpPr/>
           <p:nvPr/>
         </p:nvSpPr>
@@ -7916,7 +7763,7 @@
       </p:sp>
       <p:sp>
         <p:nvSpPr>
-          <p:cNvPr id="28" name="Shape 25"/>
+          <p:cNvPr id="26" name="Shape 23"/>
           <p:cNvSpPr/>
           <p:nvPr/>
         </p:nvSpPr>
@@ -7943,7 +7790,7 @@
       </p:sp>
       <p:sp>
         <p:nvSpPr>
-          <p:cNvPr id="29" name="Shape 26"/>
+          <p:cNvPr id="27" name="Shape 24"/>
           <p:cNvSpPr/>
           <p:nvPr/>
         </p:nvSpPr>
@@ -7966,7 +7813,7 @@
       </p:sp>
       <p:sp>
         <p:nvSpPr>
-          <p:cNvPr id="30" name="Shape 27"/>
+          <p:cNvPr id="28" name="Shape 25"/>
           <p:cNvSpPr/>
           <p:nvPr/>
         </p:nvSpPr>
@@ -7991,7 +7838,7 @@
       </p:sp>
       <p:sp>
         <p:nvSpPr>
-          <p:cNvPr id="31" name="Text 28"/>
+          <p:cNvPr id="29" name="Text 26"/>
           <p:cNvSpPr txBox="1"/>
           <p:nvPr/>
         </p:nvSpPr>
@@ -8030,7 +7877,7 @@
       </p:sp>
       <p:sp>
         <p:nvSpPr>
-          <p:cNvPr id="32" name="Text 29"/>
+          <p:cNvPr id="30" name="Text 27"/>
           <p:cNvSpPr txBox="1"/>
           <p:nvPr/>
         </p:nvSpPr>
@@ -8080,7 +7927,7 @@
       </p:sp>
       <p:sp>
         <p:nvSpPr>
-          <p:cNvPr id="33" name="Text 30"/>
+          <p:cNvPr id="31" name="Text 28"/>
           <p:cNvSpPr txBox="1"/>
           <p:nvPr/>
         </p:nvSpPr>
@@ -8130,7 +7977,7 @@
       </p:sp>
       <p:sp>
         <p:nvSpPr>
-          <p:cNvPr id="34" name="Text 31"/>
+          <p:cNvPr id="32" name="Text 29"/>
           <p:cNvSpPr txBox="1"/>
           <p:nvPr/>
         </p:nvSpPr>
@@ -8180,7 +8027,7 @@
       </p:sp>
       <p:sp>
         <p:nvSpPr>
-          <p:cNvPr id="35" name="Text 32"/>
+          <p:cNvPr id="33" name="Text 30"/>
           <p:cNvSpPr txBox="1"/>
           <p:nvPr/>
         </p:nvSpPr>
@@ -8230,7 +8077,7 @@
       </p:sp>
       <p:sp>
         <p:nvSpPr>
-          <p:cNvPr id="36" name="Shape 33"/>
+          <p:cNvPr id="34" name="Shape 31"/>
           <p:cNvSpPr/>
           <p:nvPr/>
         </p:nvSpPr>
@@ -8257,7 +8104,7 @@
       </p:sp>
       <p:sp>
         <p:nvSpPr>
-          <p:cNvPr id="37" name="Shape 34"/>
+          <p:cNvPr id="35" name="Shape 32"/>
           <p:cNvSpPr/>
           <p:nvPr/>
         </p:nvSpPr>
@@ -8280,7 +8127,7 @@
       </p:sp>
       <p:sp>
         <p:nvSpPr>
-          <p:cNvPr id="38" name="Shape 35"/>
+          <p:cNvPr id="36" name="Shape 33"/>
           <p:cNvSpPr/>
           <p:nvPr/>
         </p:nvSpPr>
@@ -8305,7 +8152,7 @@
       </p:sp>
       <p:sp>
         <p:nvSpPr>
-          <p:cNvPr id="39" name="Text 36"/>
+          <p:cNvPr id="37" name="Text 34"/>
           <p:cNvSpPr txBox="1"/>
           <p:nvPr/>
         </p:nvSpPr>
@@ -8344,7 +8191,7 @@
       </p:sp>
       <p:sp>
         <p:nvSpPr>
-          <p:cNvPr id="40" name="Text 37"/>
+          <p:cNvPr id="38" name="Text 35"/>
           <p:cNvSpPr txBox="1"/>
           <p:nvPr/>
         </p:nvSpPr>
@@ -8383,7 +8230,7 @@
       </p:sp>
       <p:sp>
         <p:nvSpPr>
-          <p:cNvPr id="41" name="Shape 38"/>
+          <p:cNvPr id="39" name="Shape 36"/>
           <p:cNvSpPr/>
           <p:nvPr/>
         </p:nvSpPr>
@@ -8408,7 +8255,7 @@
       </p:sp>
       <p:sp>
         <p:nvSpPr>
-          <p:cNvPr id="42" name="Text 39"/>
+          <p:cNvPr id="40" name="Text 37"/>
           <p:cNvSpPr txBox="1"/>
           <p:nvPr/>
         </p:nvSpPr>
@@ -8447,7 +8294,7 @@
       </p:sp>
       <p:sp>
         <p:nvSpPr>
-          <p:cNvPr id="43" name="Text 40"/>
+          <p:cNvPr id="41" name="Text 38"/>
           <p:cNvSpPr txBox="1"/>
           <p:nvPr/>
         </p:nvSpPr>
@@ -8486,7 +8333,7 @@
       </p:sp>
       <p:sp>
         <p:nvSpPr>
-          <p:cNvPr id="44" name="Shape 41"/>
+          <p:cNvPr id="42" name="Shape 39"/>
           <p:cNvSpPr/>
           <p:nvPr/>
         </p:nvSpPr>
@@ -8511,7 +8358,7 @@
       </p:sp>
       <p:sp>
         <p:nvSpPr>
-          <p:cNvPr id="45" name="Text 42"/>
+          <p:cNvPr id="43" name="Text 40"/>
           <p:cNvSpPr txBox="1"/>
           <p:nvPr/>
         </p:nvSpPr>
@@ -8550,7 +8397,7 @@
       </p:sp>
       <p:sp>
         <p:nvSpPr>
-          <p:cNvPr id="46" name="Text 43"/>
+          <p:cNvPr id="44" name="Text 41"/>
           <p:cNvSpPr txBox="1"/>
           <p:nvPr/>
         </p:nvSpPr>
@@ -8589,7 +8436,7 @@
       </p:sp>
       <p:sp>
         <p:nvSpPr>
-          <p:cNvPr id="47" name="Shape 44"/>
+          <p:cNvPr id="45" name="Shape 42"/>
           <p:cNvSpPr/>
           <p:nvPr/>
         </p:nvSpPr>
@@ -8614,7 +8461,7 @@
       </p:sp>
       <p:sp>
         <p:nvSpPr>
-          <p:cNvPr id="48" name="Text 45"/>
+          <p:cNvPr id="46" name="Text 43"/>
           <p:cNvSpPr txBox="1"/>
           <p:nvPr/>
         </p:nvSpPr>
@@ -8653,7 +8500,7 @@
       </p:sp>
       <p:sp>
         <p:nvSpPr>
-          <p:cNvPr id="49" name="Text 46"/>
+          <p:cNvPr id="47" name="Text 44"/>
           <p:cNvSpPr txBox="1"/>
           <p:nvPr/>
         </p:nvSpPr>
@@ -8852,39 +8699,14 @@
       </p:pic>
       <p:sp>
         <p:nvSpPr>
-          <p:cNvPr id="6" name="Shape 3"/>
-          <p:cNvSpPr/>
-          <p:nvPr/>
-        </p:nvSpPr>
-        <p:spPr>
-          <a:xfrm>
-            <a:off x="0" y="4846320"/>
-            <a:ext cx="9144000" cy="297180"/>
-          </a:xfrm>
-          <a:prstGeom prst="rect">
-            <a:avLst/>
-          </a:prstGeom>
-          <a:solidFill>
-            <a:srgbClr val="0070C0"/>
-          </a:solidFill>
-          <a:ln w="12700">
-            <a:solidFill>
-              <a:srgbClr val="0070C0"/>
-            </a:solidFill>
-            <a:prstDash val="solid"/>
-          </a:ln>
-        </p:spPr>
-      </p:sp>
-      <p:sp>
-        <p:nvSpPr>
-          <p:cNvPr id="7" name="Text 4"/>
-          <p:cNvSpPr txBox="1"/>
-          <p:nvPr/>
-        </p:nvSpPr>
-        <p:spPr>
-          <a:xfrm>
-            <a:off x="0" y="4846320"/>
-            <a:ext cx="9144000" cy="297180"/>
+          <p:cNvPr id="6" name="Text 3"/>
+          <p:cNvSpPr txBox="1"/>
+          <p:nvPr/>
+        </p:nvSpPr>
+        <p:spPr>
+          <a:xfrm>
+            <a:off x="8229600" y="4809744"/>
+            <a:ext cx="640080" cy="256032"/>
           </a:xfrm>
           <a:prstGeom prst="rect">
             <a:avLst/>
@@ -8896,52 +8718,13 @@
           <a:bodyPr wrap="square" lIns="0" tIns="0" rIns="0" bIns="0" rtlCol="0" anchor="ctr"/>
           <a:lstStyle/>
           <a:p>
-            <a:pPr marL="0" indent="0" algn="ctr">
-              <a:buNone/>
-            </a:pPr>
-            <a:r>
-              <a:rPr lang="en-US" sz="900" dirty="0">
-                <a:solidFill>
-                  <a:srgbClr val="FFFFFF"/>
-                </a:solidFill>
-                <a:latin typeface="Arial" pitchFamily="34" charset="0"/>
-                <a:ea typeface="Arial" pitchFamily="34" charset="-122"/>
-                <a:cs typeface="Arial" pitchFamily="34" charset="-120"/>
-              </a:rPr>
-              <a:t>@SIH Idea submission- Template</a:t>
-            </a:r>
-            <a:endParaRPr lang="en-US" sz="900" dirty="0"/>
-          </a:p>
-        </p:txBody>
-      </p:sp>
-      <p:sp>
-        <p:nvSpPr>
-          <p:cNvPr id="8" name="Text 5"/>
-          <p:cNvSpPr txBox="1"/>
-          <p:nvPr/>
-        </p:nvSpPr>
-        <p:spPr>
-          <a:xfrm>
-            <a:off x="8046720" y="4846320"/>
-            <a:ext cx="822960" cy="297180"/>
-          </a:xfrm>
-          <a:prstGeom prst="rect">
-            <a:avLst/>
-          </a:prstGeom>
-          <a:noFill/>
-          <a:ln/>
-        </p:spPr>
-        <p:txBody>
-          <a:bodyPr wrap="square" lIns="0" tIns="0" rIns="0" bIns="0" rtlCol="0" anchor="ctr"/>
-          <a:lstStyle/>
-          <a:p>
             <a:pPr marL="0" indent="0" algn="r">
               <a:buNone/>
             </a:pPr>
             <a:r>
-              <a:rPr lang="en-US" sz="900" b="1" dirty="0">
-                <a:solidFill>
-                  <a:srgbClr val="FFFFFF"/>
+              <a:rPr lang="en-US" sz="1000" b="1" dirty="0">
+                <a:solidFill>
+                  <a:srgbClr val="6B7280"/>
                 </a:solidFill>
                 <a:latin typeface="Arial" pitchFamily="34" charset="0"/>
                 <a:ea typeface="Arial" pitchFamily="34" charset="-122"/>
@@ -8949,13 +8732,13 @@
               </a:rPr>
               <a:t>5</a:t>
             </a:r>
-            <a:endParaRPr lang="en-US" sz="900" dirty="0"/>
-          </a:p>
-        </p:txBody>
-      </p:sp>
-      <p:sp>
-        <p:nvSpPr>
-          <p:cNvPr id="9" name="Shape 6"/>
+            <a:endParaRPr lang="en-US" sz="1000" dirty="0"/>
+          </a:p>
+        </p:txBody>
+      </p:sp>
+      <p:sp>
+        <p:nvSpPr>
+          <p:cNvPr id="7" name="Shape 4"/>
           <p:cNvSpPr/>
           <p:nvPr/>
         </p:nvSpPr>
@@ -8980,7 +8763,7 @@
       </p:sp>
       <p:sp>
         <p:nvSpPr>
-          <p:cNvPr id="10" name="Shape 7"/>
+          <p:cNvPr id="8" name="Shape 5"/>
           <p:cNvSpPr/>
           <p:nvPr/>
         </p:nvSpPr>
@@ -9005,7 +8788,7 @@
       </p:sp>
       <p:sp>
         <p:nvSpPr>
-          <p:cNvPr id="11" name="Shape 8"/>
+          <p:cNvPr id="9" name="Shape 6"/>
           <p:cNvSpPr/>
           <p:nvPr/>
         </p:nvSpPr>
@@ -9028,7 +8811,7 @@
       </p:sp>
       <p:sp>
         <p:nvSpPr>
-          <p:cNvPr id="12" name="Text 9"/>
+          <p:cNvPr id="10" name="Text 7"/>
           <p:cNvSpPr txBox="1"/>
           <p:nvPr/>
         </p:nvSpPr>
@@ -9067,7 +8850,7 @@
       </p:sp>
       <p:sp>
         <p:nvSpPr>
-          <p:cNvPr id="13" name="Text 10"/>
+          <p:cNvPr id="11" name="Text 8"/>
           <p:cNvSpPr txBox="1"/>
           <p:nvPr/>
         </p:nvSpPr>
@@ -9106,7 +8889,7 @@
       </p:sp>
       <p:sp>
         <p:nvSpPr>
-          <p:cNvPr id="14" name="Shape 11"/>
+          <p:cNvPr id="12" name="Shape 9"/>
           <p:cNvSpPr/>
           <p:nvPr/>
         </p:nvSpPr>
@@ -9131,7 +8914,7 @@
       </p:sp>
       <p:sp>
         <p:nvSpPr>
-          <p:cNvPr id="15" name="Text 12"/>
+          <p:cNvPr id="13" name="Text 10"/>
           <p:cNvSpPr txBox="1"/>
           <p:nvPr/>
         </p:nvSpPr>
@@ -9170,7 +8953,7 @@
       </p:sp>
       <p:sp>
         <p:nvSpPr>
-          <p:cNvPr id="16" name="Shape 13"/>
+          <p:cNvPr id="14" name="Shape 11"/>
           <p:cNvSpPr/>
           <p:nvPr/>
         </p:nvSpPr>
@@ -9192,7 +8975,7 @@
       </p:sp>
       <p:sp>
         <p:nvSpPr>
-          <p:cNvPr id="17" name="Text 14"/>
+          <p:cNvPr id="15" name="Text 12"/>
           <p:cNvSpPr txBox="1"/>
           <p:nvPr/>
         </p:nvSpPr>
@@ -9231,7 +9014,7 @@
       </p:sp>
       <p:sp>
         <p:nvSpPr>
-          <p:cNvPr id="18" name="Text 15"/>
+          <p:cNvPr id="16" name="Text 13"/>
           <p:cNvSpPr txBox="1"/>
           <p:nvPr/>
         </p:nvSpPr>
@@ -9270,7 +9053,7 @@
       </p:sp>
       <p:sp>
         <p:nvSpPr>
-          <p:cNvPr id="19" name="Shape 16"/>
+          <p:cNvPr id="17" name="Shape 14"/>
           <p:cNvSpPr/>
           <p:nvPr/>
         </p:nvSpPr>
@@ -9295,7 +9078,7 @@
       </p:sp>
       <p:sp>
         <p:nvSpPr>
-          <p:cNvPr id="20" name="Text 17"/>
+          <p:cNvPr id="18" name="Text 15"/>
           <p:cNvSpPr txBox="1"/>
           <p:nvPr/>
         </p:nvSpPr>
@@ -9334,7 +9117,7 @@
       </p:sp>
       <p:sp>
         <p:nvSpPr>
-          <p:cNvPr id="21" name="Shape 18"/>
+          <p:cNvPr id="19" name="Shape 16"/>
           <p:cNvSpPr/>
           <p:nvPr/>
         </p:nvSpPr>
@@ -9356,7 +9139,7 @@
       </p:sp>
       <p:sp>
         <p:nvSpPr>
-          <p:cNvPr id="22" name="Text 19"/>
+          <p:cNvPr id="20" name="Text 17"/>
           <p:cNvSpPr txBox="1"/>
           <p:nvPr/>
         </p:nvSpPr>
@@ -9395,7 +9178,7 @@
       </p:sp>
       <p:sp>
         <p:nvSpPr>
-          <p:cNvPr id="23" name="Text 20"/>
+          <p:cNvPr id="21" name="Text 18"/>
           <p:cNvSpPr txBox="1"/>
           <p:nvPr/>
         </p:nvSpPr>
@@ -9434,7 +9217,7 @@
       </p:sp>
       <p:sp>
         <p:nvSpPr>
-          <p:cNvPr id="24" name="Shape 21"/>
+          <p:cNvPr id="22" name="Shape 19"/>
           <p:cNvSpPr/>
           <p:nvPr/>
         </p:nvSpPr>
@@ -9459,7 +9242,7 @@
       </p:sp>
       <p:sp>
         <p:nvSpPr>
-          <p:cNvPr id="25" name="Text 22"/>
+          <p:cNvPr id="23" name="Text 20"/>
           <p:cNvSpPr txBox="1"/>
           <p:nvPr/>
         </p:nvSpPr>
@@ -9498,7 +9281,7 @@
       </p:sp>
       <p:sp>
         <p:nvSpPr>
-          <p:cNvPr id="26" name="Shape 23"/>
+          <p:cNvPr id="24" name="Shape 21"/>
           <p:cNvSpPr/>
           <p:nvPr/>
         </p:nvSpPr>
@@ -9520,7 +9303,7 @@
       </p:sp>
       <p:sp>
         <p:nvSpPr>
-          <p:cNvPr id="27" name="Text 24"/>
+          <p:cNvPr id="25" name="Text 22"/>
           <p:cNvSpPr txBox="1"/>
           <p:nvPr/>
         </p:nvSpPr>
@@ -9559,7 +9342,7 @@
       </p:sp>
       <p:sp>
         <p:nvSpPr>
-          <p:cNvPr id="28" name="Text 25"/>
+          <p:cNvPr id="26" name="Text 23"/>
           <p:cNvSpPr txBox="1"/>
           <p:nvPr/>
         </p:nvSpPr>
@@ -9598,7 +9381,7 @@
       </p:sp>
       <p:sp>
         <p:nvSpPr>
-          <p:cNvPr id="29" name="Shape 26"/>
+          <p:cNvPr id="27" name="Shape 24"/>
           <p:cNvSpPr/>
           <p:nvPr/>
         </p:nvSpPr>
@@ -9623,7 +9406,7 @@
       </p:sp>
       <p:sp>
         <p:nvSpPr>
-          <p:cNvPr id="30" name="Text 27"/>
+          <p:cNvPr id="28" name="Text 25"/>
           <p:cNvSpPr txBox="1"/>
           <p:nvPr/>
         </p:nvSpPr>
@@ -9662,7 +9445,7 @@
       </p:sp>
       <p:sp>
         <p:nvSpPr>
-          <p:cNvPr id="31" name="Shape 28"/>
+          <p:cNvPr id="29" name="Shape 26"/>
           <p:cNvSpPr/>
           <p:nvPr/>
         </p:nvSpPr>
@@ -9684,7 +9467,7 @@
       </p:sp>
       <p:sp>
         <p:nvSpPr>
-          <p:cNvPr id="32" name="Text 29"/>
+          <p:cNvPr id="30" name="Text 27"/>
           <p:cNvSpPr txBox="1"/>
           <p:nvPr/>
         </p:nvSpPr>
@@ -9723,7 +9506,7 @@
       </p:sp>
       <p:sp>
         <p:nvSpPr>
-          <p:cNvPr id="33" name="Text 30"/>
+          <p:cNvPr id="31" name="Text 28"/>
           <p:cNvSpPr txBox="1"/>
           <p:nvPr/>
         </p:nvSpPr>
@@ -9762,7 +9545,7 @@
       </p:sp>
       <p:sp>
         <p:nvSpPr>
-          <p:cNvPr id="34" name="Shape 31"/>
+          <p:cNvPr id="32" name="Shape 29"/>
           <p:cNvSpPr/>
           <p:nvPr/>
         </p:nvSpPr>
@@ -9787,7 +9570,7 @@
       </p:sp>
       <p:sp>
         <p:nvSpPr>
-          <p:cNvPr id="35" name="Text 32"/>
+          <p:cNvPr id="33" name="Text 30"/>
           <p:cNvSpPr txBox="1"/>
           <p:nvPr/>
         </p:nvSpPr>
@@ -9826,7 +9609,7 @@
       </p:sp>
       <p:sp>
         <p:nvSpPr>
-          <p:cNvPr id="36" name="Text 33"/>
+          <p:cNvPr id="34" name="Text 31"/>
           <p:cNvSpPr txBox="1"/>
           <p:nvPr/>
         </p:nvSpPr>
@@ -9865,7 +9648,7 @@
       </p:sp>
       <p:sp>
         <p:nvSpPr>
-          <p:cNvPr id="37" name="Text 34"/>
+          <p:cNvPr id="35" name="Text 32"/>
           <p:cNvSpPr txBox="1"/>
           <p:nvPr/>
         </p:nvSpPr>
@@ -9904,7 +9687,7 @@
       </p:sp>
       <p:sp>
         <p:nvSpPr>
-          <p:cNvPr id="38" name="Shape 35"/>
+          <p:cNvPr id="36" name="Shape 33"/>
           <p:cNvSpPr/>
           <p:nvPr/>
         </p:nvSpPr>
@@ -9929,7 +9712,7 @@
       </p:sp>
       <p:sp>
         <p:nvSpPr>
-          <p:cNvPr id="39" name="Text 36"/>
+          <p:cNvPr id="37" name="Text 34"/>
           <p:cNvSpPr txBox="1"/>
           <p:nvPr/>
         </p:nvSpPr>
@@ -9968,7 +9751,7 @@
       </p:sp>
       <p:sp>
         <p:nvSpPr>
-          <p:cNvPr id="40" name="Text 37"/>
+          <p:cNvPr id="38" name="Text 35"/>
           <p:cNvSpPr txBox="1"/>
           <p:nvPr/>
         </p:nvSpPr>
@@ -10007,7 +9790,7 @@
       </p:sp>
       <p:sp>
         <p:nvSpPr>
-          <p:cNvPr id="41" name="Text 38"/>
+          <p:cNvPr id="39" name="Text 36"/>
           <p:cNvSpPr txBox="1"/>
           <p:nvPr/>
         </p:nvSpPr>
@@ -10046,7 +9829,7 @@
       </p:sp>
       <p:sp>
         <p:nvSpPr>
-          <p:cNvPr id="42" name="Shape 39"/>
+          <p:cNvPr id="40" name="Shape 37"/>
           <p:cNvSpPr/>
           <p:nvPr/>
         </p:nvSpPr>
@@ -10071,7 +9854,7 @@
       </p:sp>
       <p:sp>
         <p:nvSpPr>
-          <p:cNvPr id="43" name="Text 40"/>
+          <p:cNvPr id="41" name="Text 38"/>
           <p:cNvSpPr txBox="1"/>
           <p:nvPr/>
         </p:nvSpPr>
@@ -10110,7 +9893,7 @@
       </p:sp>
       <p:sp>
         <p:nvSpPr>
-          <p:cNvPr id="44" name="Text 41"/>
+          <p:cNvPr id="42" name="Text 39"/>
           <p:cNvSpPr txBox="1"/>
           <p:nvPr/>
         </p:nvSpPr>
@@ -10149,7 +9932,7 @@
       </p:sp>
       <p:sp>
         <p:nvSpPr>
-          <p:cNvPr id="45" name="Text 42"/>
+          <p:cNvPr id="43" name="Text 40"/>
           <p:cNvSpPr txBox="1"/>
           <p:nvPr/>
         </p:nvSpPr>
@@ -10188,7 +9971,7 @@
       </p:sp>
       <p:sp>
         <p:nvSpPr>
-          <p:cNvPr id="46" name="Shape 43"/>
+          <p:cNvPr id="44" name="Shape 41"/>
           <p:cNvSpPr/>
           <p:nvPr/>
         </p:nvSpPr>
@@ -10213,7 +9996,7 @@
       </p:sp>
       <p:sp>
         <p:nvSpPr>
-          <p:cNvPr id="47" name="Text 44"/>
+          <p:cNvPr id="45" name="Text 42"/>
           <p:cNvSpPr txBox="1"/>
           <p:nvPr/>
         </p:nvSpPr>
@@ -10252,7 +10035,7 @@
       </p:sp>
       <p:sp>
         <p:nvSpPr>
-          <p:cNvPr id="48" name="Text 45"/>
+          <p:cNvPr id="46" name="Text 43"/>
           <p:cNvSpPr txBox="1"/>
           <p:nvPr/>
         </p:nvSpPr>
@@ -10291,7 +10074,7 @@
       </p:sp>
       <p:sp>
         <p:nvSpPr>
-          <p:cNvPr id="49" name="Text 46"/>
+          <p:cNvPr id="47" name="Text 44"/>
           <p:cNvSpPr txBox="1"/>
           <p:nvPr/>
         </p:nvSpPr>
@@ -10330,7 +10113,7 @@
       </p:sp>
       <p:sp>
         <p:nvSpPr>
-          <p:cNvPr id="50" name="Shape 47"/>
+          <p:cNvPr id="48" name="Shape 45"/>
           <p:cNvSpPr/>
           <p:nvPr/>
         </p:nvSpPr>
@@ -10355,7 +10138,7 @@
       </p:sp>
       <p:sp>
         <p:nvSpPr>
-          <p:cNvPr id="51" name="Text 48"/>
+          <p:cNvPr id="49" name="Text 46"/>
           <p:cNvSpPr txBox="1"/>
           <p:nvPr/>
         </p:nvSpPr>
@@ -10394,7 +10177,7 @@
       </p:sp>
       <p:graphicFrame>
         <p:nvGraphicFramePr>
-          <p:cNvPr id="52" name="Chart 0"/>
+          <p:cNvPr id="50" name="Chart 0"/>
           <p:cNvGraphicFramePr/>
           <p:nvPr/>
         </p:nvGraphicFramePr>
@@ -10410,7 +10193,7 @@
       </p:graphicFrame>
       <p:sp>
         <p:nvSpPr>
-          <p:cNvPr id="53" name="Text 49"/>
+          <p:cNvPr id="51" name="Text 47"/>
           <p:cNvSpPr txBox="1"/>
           <p:nvPr/>
         </p:nvSpPr>
@@ -10449,7 +10232,7 @@
       </p:sp>
       <p:sp>
         <p:nvSpPr>
-          <p:cNvPr id="54" name="Text 50"/>
+          <p:cNvPr id="52" name="Text 48"/>
           <p:cNvSpPr txBox="1"/>
           <p:nvPr/>
         </p:nvSpPr>
@@ -10488,7 +10271,7 @@
       </p:sp>
       <p:pic>
         <p:nvPicPr>
-          <p:cNvPr id="55" name="Image 1" descr="preencoded.png"/>
+          <p:cNvPr id="53" name="Image 1" descr="preencoded.png"/>
           <p:cNvPicPr>
             <a:picLocks noChangeAspect="1"/>
           </p:cNvPicPr>
@@ -10512,7 +10295,7 @@
       </p:pic>
       <p:pic>
         <p:nvPicPr>
-          <p:cNvPr id="56" name="Image 2" descr="preencoded.png"/>
+          <p:cNvPr id="54" name="Image 2" descr="preencoded.png"/>
           <p:cNvPicPr>
             <a:picLocks noChangeAspect="1"/>
           </p:cNvPicPr>
@@ -10535,7 +10318,7 @@
       </p:pic>
       <p:sp>
         <p:nvSpPr>
-          <p:cNvPr id="57" name="Text 51"/>
+          <p:cNvPr id="55" name="Text 49"/>
           <p:cNvSpPr txBox="1"/>
           <p:nvPr/>
         </p:nvSpPr>
@@ -10574,7 +10357,7 @@
       </p:sp>
       <p:sp>
         <p:nvSpPr>
-          <p:cNvPr id="58" name="Text 52"/>
+          <p:cNvPr id="56" name="Text 50"/>
           <p:cNvSpPr txBox="1"/>
           <p:nvPr/>
         </p:nvSpPr>
@@ -10773,39 +10556,14 @@
       </p:pic>
       <p:sp>
         <p:nvSpPr>
-          <p:cNvPr id="6" name="Shape 3"/>
-          <p:cNvSpPr/>
-          <p:nvPr/>
-        </p:nvSpPr>
-        <p:spPr>
-          <a:xfrm>
-            <a:off x="0" y="4846320"/>
-            <a:ext cx="9144000" cy="297180"/>
-          </a:xfrm>
-          <a:prstGeom prst="rect">
-            <a:avLst/>
-          </a:prstGeom>
-          <a:solidFill>
-            <a:srgbClr val="0070C0"/>
-          </a:solidFill>
-          <a:ln w="12700">
-            <a:solidFill>
-              <a:srgbClr val="0070C0"/>
-            </a:solidFill>
-            <a:prstDash val="solid"/>
-          </a:ln>
-        </p:spPr>
-      </p:sp>
-      <p:sp>
-        <p:nvSpPr>
-          <p:cNvPr id="7" name="Text 4"/>
-          <p:cNvSpPr txBox="1"/>
-          <p:nvPr/>
-        </p:nvSpPr>
-        <p:spPr>
-          <a:xfrm>
-            <a:off x="0" y="4846320"/>
-            <a:ext cx="9144000" cy="297180"/>
+          <p:cNvPr id="6" name="Text 3"/>
+          <p:cNvSpPr txBox="1"/>
+          <p:nvPr/>
+        </p:nvSpPr>
+        <p:spPr>
+          <a:xfrm>
+            <a:off x="8229600" y="4809744"/>
+            <a:ext cx="640080" cy="256032"/>
           </a:xfrm>
           <a:prstGeom prst="rect">
             <a:avLst/>
@@ -10817,52 +10575,13 @@
           <a:bodyPr wrap="square" lIns="0" tIns="0" rIns="0" bIns="0" rtlCol="0" anchor="ctr"/>
           <a:lstStyle/>
           <a:p>
-            <a:pPr marL="0" indent="0" algn="ctr">
-              <a:buNone/>
-            </a:pPr>
-            <a:r>
-              <a:rPr lang="en-US" sz="900" dirty="0">
-                <a:solidFill>
-                  <a:srgbClr val="FFFFFF"/>
-                </a:solidFill>
-                <a:latin typeface="Arial" pitchFamily="34" charset="0"/>
-                <a:ea typeface="Arial" pitchFamily="34" charset="-122"/>
-                <a:cs typeface="Arial" pitchFamily="34" charset="-120"/>
-              </a:rPr>
-              <a:t>@SIH Idea submission- Template</a:t>
-            </a:r>
-            <a:endParaRPr lang="en-US" sz="900" dirty="0"/>
-          </a:p>
-        </p:txBody>
-      </p:sp>
-      <p:sp>
-        <p:nvSpPr>
-          <p:cNvPr id="8" name="Text 5"/>
-          <p:cNvSpPr txBox="1"/>
-          <p:nvPr/>
-        </p:nvSpPr>
-        <p:spPr>
-          <a:xfrm>
-            <a:off x="8046720" y="4846320"/>
-            <a:ext cx="822960" cy="297180"/>
-          </a:xfrm>
-          <a:prstGeom prst="rect">
-            <a:avLst/>
-          </a:prstGeom>
-          <a:noFill/>
-          <a:ln/>
-        </p:spPr>
-        <p:txBody>
-          <a:bodyPr wrap="square" lIns="0" tIns="0" rIns="0" bIns="0" rtlCol="0" anchor="ctr"/>
-          <a:lstStyle/>
-          <a:p>
             <a:pPr marL="0" indent="0" algn="r">
               <a:buNone/>
             </a:pPr>
             <a:r>
-              <a:rPr lang="en-US" sz="900" b="1" dirty="0">
-                <a:solidFill>
-                  <a:srgbClr val="FFFFFF"/>
+              <a:rPr lang="en-US" sz="1000" b="1" dirty="0">
+                <a:solidFill>
+                  <a:srgbClr val="6B7280"/>
                 </a:solidFill>
                 <a:latin typeface="Arial" pitchFamily="34" charset="0"/>
                 <a:ea typeface="Arial" pitchFamily="34" charset="-122"/>
@@ -10870,13 +10589,13 @@
               </a:rPr>
               <a:t>6</a:t>
             </a:r>
-            <a:endParaRPr lang="en-US" sz="900" dirty="0"/>
-          </a:p>
-        </p:txBody>
-      </p:sp>
-      <p:sp>
-        <p:nvSpPr>
-          <p:cNvPr id="9" name="Shape 6"/>
+            <a:endParaRPr lang="en-US" sz="1000" dirty="0"/>
+          </a:p>
+        </p:txBody>
+      </p:sp>
+      <p:sp>
+        <p:nvSpPr>
+          <p:cNvPr id="7" name="Shape 4"/>
           <p:cNvSpPr/>
           <p:nvPr/>
         </p:nvSpPr>
@@ -10900,7 +10619,7 @@
       </p:sp>
       <p:sp>
         <p:nvSpPr>
-          <p:cNvPr id="10" name="Text 7"/>
+          <p:cNvPr id="8" name="Text 5"/>
           <p:cNvSpPr txBox="1"/>
           <p:nvPr/>
         </p:nvSpPr>
@@ -10939,7 +10658,7 @@
       </p:sp>
       <p:sp>
         <p:nvSpPr>
-          <p:cNvPr id="11" name="Shape 8"/>
+          <p:cNvPr id="9" name="Shape 6"/>
           <p:cNvSpPr/>
           <p:nvPr/>
         </p:nvSpPr>
@@ -10964,7 +10683,7 @@
       </p:sp>
       <p:sp>
         <p:nvSpPr>
-          <p:cNvPr id="12" name="Text 9"/>
+          <p:cNvPr id="10" name="Text 7"/>
           <p:cNvSpPr txBox="1"/>
           <p:nvPr/>
         </p:nvSpPr>
@@ -11037,7 +10756,7 @@
       </p:sp>
       <p:sp>
         <p:nvSpPr>
-          <p:cNvPr id="13" name="Text 10"/>
+          <p:cNvPr id="11" name="Text 8"/>
           <p:cNvSpPr txBox="1"/>
           <p:nvPr/>
         </p:nvSpPr>
@@ -11083,7 +10802,7 @@
       </p:sp>
       <p:sp>
         <p:nvSpPr>
-          <p:cNvPr id="14" name="Text 11"/>
+          <p:cNvPr id="12" name="Text 9"/>
           <p:cNvSpPr txBox="1"/>
           <p:nvPr/>
         </p:nvSpPr>
@@ -11122,7 +10841,7 @@
       </p:sp>
       <p:sp>
         <p:nvSpPr>
-          <p:cNvPr id="15" name="Shape 12"/>
+          <p:cNvPr id="13" name="Shape 10"/>
           <p:cNvSpPr/>
           <p:nvPr/>
         </p:nvSpPr>
@@ -11147,7 +10866,7 @@
       </p:sp>
       <p:sp>
         <p:nvSpPr>
-          <p:cNvPr id="16" name="Text 13"/>
+          <p:cNvPr id="14" name="Text 11"/>
           <p:cNvSpPr txBox="1"/>
           <p:nvPr/>
         </p:nvSpPr>
@@ -11220,7 +10939,7 @@
       </p:sp>
       <p:sp>
         <p:nvSpPr>
-          <p:cNvPr id="17" name="Text 14"/>
+          <p:cNvPr id="15" name="Text 12"/>
           <p:cNvSpPr txBox="1"/>
           <p:nvPr/>
         </p:nvSpPr>
@@ -11266,7 +10985,7 @@
       </p:sp>
       <p:sp>
         <p:nvSpPr>
-          <p:cNvPr id="18" name="Text 15"/>
+          <p:cNvPr id="16" name="Text 13"/>
           <p:cNvSpPr txBox="1"/>
           <p:nvPr/>
         </p:nvSpPr>
@@ -11305,7 +11024,7 @@
       </p:sp>
       <p:sp>
         <p:nvSpPr>
-          <p:cNvPr id="19" name="Shape 16"/>
+          <p:cNvPr id="17" name="Shape 14"/>
           <p:cNvSpPr/>
           <p:nvPr/>
         </p:nvSpPr>
@@ -11330,7 +11049,7 @@
       </p:sp>
       <p:sp>
         <p:nvSpPr>
-          <p:cNvPr id="20" name="Text 17"/>
+          <p:cNvPr id="18" name="Text 15"/>
           <p:cNvSpPr txBox="1"/>
           <p:nvPr/>
         </p:nvSpPr>
@@ -11403,7 +11122,7 @@
       </p:sp>
       <p:sp>
         <p:nvSpPr>
-          <p:cNvPr id="21" name="Text 18"/>
+          <p:cNvPr id="19" name="Text 16"/>
           <p:cNvSpPr txBox="1"/>
           <p:nvPr/>
         </p:nvSpPr>
@@ -11449,7 +11168,7 @@
       </p:sp>
       <p:sp>
         <p:nvSpPr>
-          <p:cNvPr id="22" name="Text 19"/>
+          <p:cNvPr id="20" name="Text 17"/>
           <p:cNvSpPr txBox="1"/>
           <p:nvPr/>
         </p:nvSpPr>
@@ -11488,7 +11207,7 @@
       </p:sp>
       <p:sp>
         <p:nvSpPr>
-          <p:cNvPr id="23" name="Shape 20"/>
+          <p:cNvPr id="21" name="Shape 18"/>
           <p:cNvSpPr/>
           <p:nvPr/>
         </p:nvSpPr>
@@ -11513,7 +11232,7 @@
       </p:sp>
       <p:sp>
         <p:nvSpPr>
-          <p:cNvPr id="24" name="Text 21"/>
+          <p:cNvPr id="22" name="Text 19"/>
           <p:cNvSpPr txBox="1"/>
           <p:nvPr/>
         </p:nvSpPr>
@@ -11586,7 +11305,7 @@
       </p:sp>
       <p:sp>
         <p:nvSpPr>
-          <p:cNvPr id="25" name="Text 22"/>
+          <p:cNvPr id="23" name="Text 20"/>
           <p:cNvSpPr txBox="1"/>
           <p:nvPr/>
         </p:nvSpPr>
@@ -11632,7 +11351,7 @@
       </p:sp>
       <p:sp>
         <p:nvSpPr>
-          <p:cNvPr id="26" name="Text 23"/>
+          <p:cNvPr id="24" name="Text 21"/>
           <p:cNvSpPr txBox="1"/>
           <p:nvPr/>
         </p:nvSpPr>
@@ -11671,7 +11390,7 @@
       </p:sp>
       <p:sp>
         <p:nvSpPr>
-          <p:cNvPr id="27" name="Shape 24"/>
+          <p:cNvPr id="25" name="Shape 22"/>
           <p:cNvSpPr/>
           <p:nvPr/>
         </p:nvSpPr>
@@ -11696,7 +11415,7 @@
       </p:sp>
       <p:sp>
         <p:nvSpPr>
-          <p:cNvPr id="28" name="Text 25"/>
+          <p:cNvPr id="26" name="Text 23"/>
           <p:cNvSpPr txBox="1"/>
           <p:nvPr/>
         </p:nvSpPr>
@@ -11769,7 +11488,7 @@
       </p:sp>
       <p:sp>
         <p:nvSpPr>
-          <p:cNvPr id="29" name="Text 26"/>
+          <p:cNvPr id="27" name="Text 24"/>
           <p:cNvSpPr txBox="1"/>
           <p:nvPr/>
         </p:nvSpPr>
@@ -11815,7 +11534,7 @@
       </p:sp>
       <p:sp>
         <p:nvSpPr>
-          <p:cNvPr id="30" name="Text 27"/>
+          <p:cNvPr id="28" name="Text 25"/>
           <p:cNvSpPr txBox="1"/>
           <p:nvPr/>
         </p:nvSpPr>
@@ -11854,7 +11573,7 @@
       </p:sp>
       <p:sp>
         <p:nvSpPr>
-          <p:cNvPr id="31" name="Shape 28"/>
+          <p:cNvPr id="29" name="Shape 26"/>
           <p:cNvSpPr/>
           <p:nvPr/>
         </p:nvSpPr>
@@ -11879,7 +11598,7 @@
       </p:sp>
       <p:sp>
         <p:nvSpPr>
-          <p:cNvPr id="32" name="Text 29"/>
+          <p:cNvPr id="30" name="Text 27"/>
           <p:cNvSpPr txBox="1"/>
           <p:nvPr/>
         </p:nvSpPr>
@@ -11952,7 +11671,7 @@
       </p:sp>
       <p:sp>
         <p:nvSpPr>
-          <p:cNvPr id="33" name="Text 30"/>
+          <p:cNvPr id="31" name="Text 28"/>
           <p:cNvSpPr txBox="1"/>
           <p:nvPr/>
         </p:nvSpPr>
@@ -11998,7 +11717,7 @@
       </p:sp>
       <p:sp>
         <p:nvSpPr>
-          <p:cNvPr id="34" name="Text 31"/>
+          <p:cNvPr id="32" name="Text 29"/>
           <p:cNvSpPr txBox="1"/>
           <p:nvPr/>
         </p:nvSpPr>
@@ -12037,7 +11756,7 @@
       </p:sp>
       <p:sp>
         <p:nvSpPr>
-          <p:cNvPr id="35" name="Shape 32"/>
+          <p:cNvPr id="33" name="Shape 30"/>
           <p:cNvSpPr/>
           <p:nvPr/>
         </p:nvSpPr>
@@ -12062,7 +11781,7 @@
       </p:sp>
       <p:sp>
         <p:nvSpPr>
-          <p:cNvPr id="36" name="Text 33"/>
+          <p:cNvPr id="34" name="Text 31"/>
           <p:cNvSpPr txBox="1"/>
           <p:nvPr/>
         </p:nvSpPr>
@@ -12135,7 +11854,7 @@
       </p:sp>
       <p:sp>
         <p:nvSpPr>
-          <p:cNvPr id="37" name="Text 34"/>
+          <p:cNvPr id="35" name="Text 32"/>
           <p:cNvSpPr txBox="1"/>
           <p:nvPr/>
         </p:nvSpPr>
@@ -12181,7 +11900,7 @@
       </p:sp>
       <p:sp>
         <p:nvSpPr>
-          <p:cNvPr id="38" name="Shape 35"/>
+          <p:cNvPr id="36" name="Shape 33"/>
           <p:cNvSpPr/>
           <p:nvPr/>
         </p:nvSpPr>
@@ -12205,7 +11924,7 @@
       </p:sp>
       <p:sp>
         <p:nvSpPr>
-          <p:cNvPr id="39" name="Shape 36"/>
+          <p:cNvPr id="37" name="Shape 34"/>
           <p:cNvSpPr/>
           <p:nvPr/>
         </p:nvSpPr>
@@ -12230,7 +11949,7 @@
       </p:sp>
       <p:sp>
         <p:nvSpPr>
-          <p:cNvPr id="40" name="Text 37"/>
+          <p:cNvPr id="38" name="Text 35"/>
           <p:cNvSpPr txBox="1"/>
           <p:nvPr/>
         </p:nvSpPr>
@@ -12269,7 +11988,7 @@
       </p:sp>
       <p:sp>
         <p:nvSpPr>
-          <p:cNvPr id="41" name="Text 38"/>
+          <p:cNvPr id="39" name="Text 36"/>
           <p:cNvSpPr txBox="1"/>
           <p:nvPr/>
         </p:nvSpPr>
@@ -12308,7 +12027,7 @@
       </p:sp>
       <p:pic>
         <p:nvPicPr>
-          <p:cNvPr id="42" name="Image 1" descr="preencoded.png"/>
+          <p:cNvPr id="40" name="Image 1" descr="preencoded.png"/>
           <p:cNvPicPr>
             <a:picLocks noChangeAspect="1"/>
           </p:cNvPicPr>
@@ -12331,7 +12050,7 @@
       </p:pic>
       <p:pic>
         <p:nvPicPr>
-          <p:cNvPr id="43" name="Image 2" descr="preencoded.png"/>
+          <p:cNvPr id="41" name="Image 2" descr="preencoded.png"/>
           <p:cNvPicPr>
             <a:picLocks noChangeAspect="1"/>
           </p:cNvPicPr>
@@ -12354,7 +12073,7 @@
       </p:pic>
       <p:pic>
         <p:nvPicPr>
-          <p:cNvPr id="44" name="Image 3" descr="preencoded.png"/>
+          <p:cNvPr id="42" name="Image 3" descr="preencoded.png"/>
           <p:cNvPicPr>
             <a:picLocks noChangeAspect="1"/>
           </p:cNvPicPr>
@@ -12377,7 +12096,7 @@
       </p:pic>
       <p:sp>
         <p:nvSpPr>
-          <p:cNvPr id="45" name="Shape 39"/>
+          <p:cNvPr id="43" name="Shape 37"/>
           <p:cNvSpPr/>
           <p:nvPr/>
         </p:nvSpPr>
@@ -12404,7 +12123,7 @@
       </p:sp>
       <p:sp>
         <p:nvSpPr>
-          <p:cNvPr id="46" name="Text 40"/>
+          <p:cNvPr id="44" name="Text 38"/>
           <p:cNvSpPr txBox="1"/>
           <p:nvPr/>
         </p:nvSpPr>

</xml_diff>